<commit_message>
Add English component tank agitation slides to sifter deck
Co-authored-by: peterli0913 <peterli0913@users.noreply.github.com>
</commit_message>
<xml_diff>
--- a/Single-Shaft Rotary Sifter EN.pptx
+++ b/Single-Shaft Rotary Sifter EN.pptx
@@ -10,6 +10,8 @@
     <p:sldId id="258" r:id="rId5"/>
     <p:sldId id="259" r:id="rId6"/>
     <p:sldId id="260" r:id="rId7"/>
+    <p:sldId id="261" r:id="rId11"/>
+    <p:sldId id="262" r:id="rId12"/>
   </p:sldIdLst>
   <p:sldSz cx="12191365" cy="6858000" type="screen4x3"/>
   <p:notesSz cx="6858000" cy="9144000"/>
@@ -6710,6 +6712,2960 @@
 </p:sld>
 </file>
 
+<file path=ppt/slides/slide6.xml><?xml version="1.0" encoding="utf-8"?>
+<p:sld xmlns:a="http://schemas.openxmlformats.org/drawingml/2006/main" xmlns:p="http://schemas.openxmlformats.org/presentationml/2006/main" xmlns:r="http://schemas.openxmlformats.org/officeDocument/2006/relationships">
+  <p:cSld>
+    <p:spTree>
+      <p:nvGrpSpPr>
+        <p:cNvPr id="1" name=""/>
+        <p:cNvGrpSpPr/>
+        <p:nvPr/>
+      </p:nvGrpSpPr>
+      <p:grpSpPr/>
+      <p:sp>
+        <p:nvSpPr>
+          <p:cNvPr id="2" name="Rectangle 1"/>
+          <p:cNvSpPr/>
+          <p:nvPr/>
+        </p:nvSpPr>
+        <p:spPr>
+          <a:xfrm>
+            <a:off x="0" y="658368"/>
+            <a:ext cx="12191695" cy="12700"/>
+          </a:xfrm>
+          <a:prstGeom prst="rect">
+            <a:avLst/>
+          </a:prstGeom>
+          <a:solidFill>
+            <a:srgbClr val="366092"/>
+          </a:solidFill>
+          <a:ln>
+            <a:noFill/>
+          </a:ln>
+          <a:effectLst/>
+        </p:spPr>
+        <p:style>
+          <a:lnRef idx="1">
+            <a:schemeClr val="accent1"/>
+          </a:lnRef>
+          <a:fillRef idx="3">
+            <a:schemeClr val="accent1"/>
+          </a:fillRef>
+          <a:effectRef idx="2">
+            <a:schemeClr val="accent1"/>
+          </a:effectRef>
+          <a:fontRef idx="minor">
+            <a:schemeClr val="lt1"/>
+          </a:fontRef>
+        </p:style>
+        <p:txBody>
+          <a:bodyPr rtlCol="0" anchor="ctr"/>
+          <a:lstStyle/>
+          <a:p>
+            <a:pPr algn="ctr"/>
+          </a:p>
+        </p:txBody>
+      </p:sp>
+      <p:pic>
+        <p:nvPicPr>
+          <p:cNvPr id="3" name="Picture 2" descr="image.png"/>
+          <p:cNvPicPr>
+            <a:picLocks noChangeAspect="1"/>
+          </p:cNvPicPr>
+          <p:nvPr/>
+        </p:nvPicPr>
+        <p:blipFill>
+          <a:blip r:embed="rId2"/>
+          <a:stretch>
+            <a:fillRect/>
+          </a:stretch>
+        </p:blipFill>
+        <p:spPr>
+          <a:xfrm>
+            <a:off x="347472" y="146304"/>
+            <a:ext cx="1933042" cy="384048"/>
+          </a:xfrm>
+          <a:prstGeom prst="rect">
+            <a:avLst/>
+          </a:prstGeom>
+        </p:spPr>
+      </p:pic>
+      <p:sp>
+        <p:nvSpPr>
+          <p:cNvPr id="4" name="TextBox 3"/>
+          <p:cNvSpPr txBox="1"/>
+          <p:nvPr/>
+        </p:nvSpPr>
+        <p:spPr>
+          <a:xfrm>
+            <a:off x="3749039" y="146304"/>
+            <a:ext cx="8046720" cy="438912"/>
+          </a:xfrm>
+          <a:prstGeom prst="rect">
+            <a:avLst/>
+          </a:prstGeom>
+          <a:noFill/>
+        </p:spPr>
+        <p:txBody>
+          <a:bodyPr wrap="square" anchor="t" lIns="45720" rIns="45720" tIns="0" bIns="0">
+            <a:spAutoFit/>
+          </a:bodyPr>
+          <a:lstStyle/>
+          <a:p>
+            <a:pPr algn="r"/>
+            <a:r>
+              <a:rPr sz="2200" b="1">
+                <a:solidFill>
+                  <a:srgbClr val="366092"/>
+                </a:solidFill>
+                <a:latin typeface="Calibri" panose="020F0502020204030204"/>
+                <a:ea typeface="微软雅黑" panose="020B0503020204020204" charset="-122"/>
+                <a:cs typeface="Calibri" panose="020F0502020204030204"/>
+              </a:rPr>
+              <a:t>Preparation system: component tank agitation</a:t>
+            </a:r>
+          </a:p>
+        </p:txBody>
+      </p:sp>
+      <p:sp>
+        <p:nvSpPr>
+          <p:cNvPr id="5" name="Rectangle 4"/>
+          <p:cNvSpPr/>
+          <p:nvPr/>
+        </p:nvSpPr>
+        <p:spPr>
+          <a:xfrm>
+            <a:off x="0" y="6565392"/>
+            <a:ext cx="12191695" cy="292608"/>
+          </a:xfrm>
+          <a:prstGeom prst="rect">
+            <a:avLst/>
+          </a:prstGeom>
+          <a:solidFill>
+            <a:srgbClr val="1F4E79"/>
+          </a:solidFill>
+          <a:ln>
+            <a:noFill/>
+          </a:ln>
+          <a:effectLst/>
+        </p:spPr>
+        <p:style>
+          <a:lnRef idx="1">
+            <a:schemeClr val="accent1"/>
+          </a:lnRef>
+          <a:fillRef idx="3">
+            <a:schemeClr val="accent1"/>
+          </a:fillRef>
+          <a:effectRef idx="2">
+            <a:schemeClr val="accent1"/>
+          </a:effectRef>
+          <a:fontRef idx="minor">
+            <a:schemeClr val="lt1"/>
+          </a:fontRef>
+        </p:style>
+        <p:txBody>
+          <a:bodyPr rtlCol="0" anchor="ctr"/>
+          <a:lstStyle/>
+          <a:p>
+            <a:pPr algn="ctr"/>
+          </a:p>
+        </p:txBody>
+      </p:sp>
+      <p:sp>
+        <p:nvSpPr>
+          <p:cNvPr id="6" name="TextBox 5"/>
+          <p:cNvSpPr txBox="1"/>
+          <p:nvPr/>
+        </p:nvSpPr>
+        <p:spPr>
+          <a:xfrm>
+            <a:off x="365760" y="6583680"/>
+            <a:ext cx="11430000" cy="237744"/>
+          </a:xfrm>
+          <a:prstGeom prst="rect">
+            <a:avLst/>
+          </a:prstGeom>
+          <a:noFill/>
+        </p:spPr>
+        <p:txBody>
+          <a:bodyPr wrap="none" anchor="t" lIns="45720" rIns="45720" tIns="0" bIns="0">
+            <a:spAutoFit/>
+          </a:bodyPr>
+          <a:lstStyle/>
+          <a:p>
+            <a:pPr algn="r"/>
+            <a:r>
+              <a:rPr sz="1100" b="0">
+                <a:solidFill>
+                  <a:srgbClr val="FFFFFF"/>
+                </a:solidFill>
+                <a:latin typeface="Calibri" panose="020F0502020204030204"/>
+                <a:ea typeface="微软雅黑" panose="020B0503020204020204" charset="-122"/>
+                <a:cs typeface="Calibri" panose="020F0502020204030204"/>
+              </a:rPr>
+              <a:t>Confidential</a:t>
+            </a:r>
+          </a:p>
+        </p:txBody>
+      </p:sp>
+      <p:sp>
+        <p:nvSpPr>
+          <p:cNvPr id="7" name="Rounded Rectangle 6"/>
+          <p:cNvSpPr/>
+          <p:nvPr/>
+        </p:nvSpPr>
+        <p:spPr>
+          <a:xfrm>
+            <a:off x="384048" y="841248"/>
+            <a:ext cx="3127248" cy="2615184"/>
+          </a:xfrm>
+          <a:prstGeom prst="roundRect">
+            <a:avLst>
+              <a:gd name="adj" fmla="val 8000"/>
+            </a:avLst>
+          </a:prstGeom>
+          <a:solidFill>
+            <a:srgbClr val="F3F6FB"/>
+          </a:solidFill>
+          <a:ln w="9525">
+            <a:solidFill>
+              <a:srgbClr val="8EA9DB"/>
+            </a:solidFill>
+          </a:ln>
+          <a:effectLst/>
+        </p:spPr>
+        <p:style>
+          <a:lnRef idx="1">
+            <a:schemeClr val="accent1"/>
+          </a:lnRef>
+          <a:fillRef idx="3">
+            <a:schemeClr val="accent1"/>
+          </a:fillRef>
+          <a:effectRef idx="2">
+            <a:schemeClr val="accent1"/>
+          </a:effectRef>
+          <a:fontRef idx="minor">
+            <a:schemeClr val="lt1"/>
+          </a:fontRef>
+        </p:style>
+        <p:txBody>
+          <a:bodyPr rtlCol="0" anchor="ctr"/>
+          <a:lstStyle/>
+          <a:p>
+            <a:pPr algn="ctr"/>
+          </a:p>
+        </p:txBody>
+      </p:sp>
+      <p:pic>
+        <p:nvPicPr>
+          <p:cNvPr id="8" name="Picture 7" descr="image2.jpeg"/>
+          <p:cNvPicPr>
+            <a:picLocks noChangeAspect="1"/>
+          </p:cNvPicPr>
+          <p:nvPr/>
+        </p:nvPicPr>
+        <p:blipFill>
+          <a:blip r:embed="rId3"/>
+          <a:stretch>
+            <a:fillRect/>
+          </a:stretch>
+        </p:blipFill>
+        <p:spPr>
+          <a:xfrm>
+            <a:off x="641066" y="950976"/>
+            <a:ext cx="2613211" cy="1938528"/>
+          </a:xfrm>
+          <a:prstGeom prst="rect">
+            <a:avLst/>
+          </a:prstGeom>
+          <a:ln w="9525">
+            <a:solidFill>
+              <a:srgbClr val="8EA9DB"/>
+            </a:solidFill>
+          </a:ln>
+        </p:spPr>
+      </p:pic>
+      <p:sp>
+        <p:nvSpPr>
+          <p:cNvPr id="9" name="Oval 8"/>
+          <p:cNvSpPr/>
+          <p:nvPr/>
+        </p:nvSpPr>
+        <p:spPr>
+          <a:xfrm>
+            <a:off x="512064" y="3035808"/>
+            <a:ext cx="274320" cy="274320"/>
+          </a:xfrm>
+          <a:prstGeom prst="ellipse">
+            <a:avLst/>
+          </a:prstGeom>
+          <a:solidFill>
+            <a:srgbClr val="366092"/>
+          </a:solidFill>
+          <a:ln>
+            <a:noFill/>
+          </a:ln>
+          <a:effectLst/>
+        </p:spPr>
+        <p:style>
+          <a:lnRef idx="1">
+            <a:schemeClr val="accent1"/>
+          </a:lnRef>
+          <a:fillRef idx="3">
+            <a:schemeClr val="accent1"/>
+          </a:fillRef>
+          <a:effectRef idx="2">
+            <a:schemeClr val="accent1"/>
+          </a:effectRef>
+          <a:fontRef idx="minor">
+            <a:schemeClr val="lt1"/>
+          </a:fontRef>
+        </p:style>
+        <p:txBody>
+          <a:bodyPr rtlCol="0" anchor="ctr" wrap="none"/>
+          <a:lstStyle/>
+          <a:p>
+            <a:pPr algn="ctr"/>
+            <a:r>
+              <a:rPr sz="1200" b="1">
+                <a:solidFill>
+                  <a:srgbClr val="FFFFFF"/>
+                </a:solidFill>
+                <a:latin typeface="Calibri" panose="020F0502020204030204"/>
+                <a:ea typeface="微软雅黑" panose="020B0503020204020204" charset="-122"/>
+                <a:cs typeface="Calibri" panose="020F0502020204030204"/>
+              </a:rPr>
+              <a:t>1</a:t>
+            </a:r>
+          </a:p>
+        </p:txBody>
+      </p:sp>
+      <p:sp>
+        <p:nvSpPr>
+          <p:cNvPr id="10" name="TextBox 9"/>
+          <p:cNvSpPr txBox="1"/>
+          <p:nvPr/>
+        </p:nvSpPr>
+        <p:spPr>
+          <a:xfrm>
+            <a:off x="859536" y="3017520"/>
+            <a:ext cx="1490472" cy="310896"/>
+          </a:xfrm>
+          <a:prstGeom prst="rect">
+            <a:avLst/>
+          </a:prstGeom>
+          <a:noFill/>
+        </p:spPr>
+        <p:txBody>
+          <a:bodyPr wrap="square" anchor="ctr" lIns="45720" rIns="45720" tIns="0" bIns="0">
+            <a:spAutoFit/>
+          </a:bodyPr>
+          <a:lstStyle/>
+          <a:p>
+            <a:pPr algn="l"/>
+            <a:r>
+              <a:rPr sz="1100" b="1">
+                <a:solidFill>
+                  <a:srgbClr val="366092"/>
+                </a:solidFill>
+                <a:latin typeface="Calibri" panose="020F0502020204030204"/>
+                <a:ea typeface="微软雅黑" panose="020B0503020204020204" charset="-122"/>
+                <a:cs typeface="Calibri" panose="020F0502020204030204"/>
+              </a:rPr>
+              <a:t>1211-HPPC03-AT03</a:t>
+            </a:r>
+          </a:p>
+        </p:txBody>
+      </p:sp>
+      <p:sp>
+        <p:nvSpPr>
+          <p:cNvPr id="11" name="Rounded Rectangle 10"/>
+          <p:cNvSpPr/>
+          <p:nvPr/>
+        </p:nvSpPr>
+        <p:spPr>
+          <a:xfrm>
+            <a:off x="2441448" y="3054096"/>
+            <a:ext cx="960120" cy="256032"/>
+          </a:xfrm>
+          <a:prstGeom prst="roundRect">
+            <a:avLst>
+              <a:gd name="adj" fmla="val 50000"/>
+            </a:avLst>
+          </a:prstGeom>
+          <a:solidFill>
+            <a:srgbClr val="2E7D32"/>
+          </a:solidFill>
+          <a:ln>
+            <a:noFill/>
+          </a:ln>
+          <a:effectLst/>
+        </p:spPr>
+        <p:style>
+          <a:lnRef idx="1">
+            <a:schemeClr val="accent1"/>
+          </a:lnRef>
+          <a:fillRef idx="3">
+            <a:schemeClr val="accent1"/>
+          </a:fillRef>
+          <a:effectRef idx="2">
+            <a:schemeClr val="accent1"/>
+          </a:effectRef>
+          <a:fontRef idx="minor">
+            <a:schemeClr val="lt1"/>
+          </a:fontRef>
+        </p:style>
+        <p:txBody>
+          <a:bodyPr rtlCol="0" anchor="ctr" wrap="none"/>
+          <a:lstStyle/>
+          <a:p>
+            <a:pPr algn="ctr"/>
+            <a:r>
+              <a:rPr sz="900" b="1">
+                <a:solidFill>
+                  <a:srgbClr val="FFFFFF"/>
+                </a:solidFill>
+                <a:latin typeface="Calibri" panose="020F0502020204030204"/>
+                <a:ea typeface="微软雅黑" panose="020B0503020204020204" charset="-122"/>
+                <a:cs typeface="Calibri" panose="020F0502020204030204"/>
+              </a:rPr>
+              <a:t>Compliant</a:t>
+            </a:r>
+          </a:p>
+        </p:txBody>
+      </p:sp>
+      <p:sp>
+        <p:nvSpPr>
+          <p:cNvPr id="12" name="Rounded Rectangle 11"/>
+          <p:cNvSpPr/>
+          <p:nvPr/>
+        </p:nvSpPr>
+        <p:spPr>
+          <a:xfrm>
+            <a:off x="3712463" y="841248"/>
+            <a:ext cx="3127248" cy="2615184"/>
+          </a:xfrm>
+          <a:prstGeom prst="roundRect">
+            <a:avLst>
+              <a:gd name="adj" fmla="val 8000"/>
+            </a:avLst>
+          </a:prstGeom>
+          <a:solidFill>
+            <a:srgbClr val="F3F6FB"/>
+          </a:solidFill>
+          <a:ln w="9525">
+            <a:solidFill>
+              <a:srgbClr val="8EA9DB"/>
+            </a:solidFill>
+          </a:ln>
+          <a:effectLst/>
+        </p:spPr>
+        <p:style>
+          <a:lnRef idx="1">
+            <a:schemeClr val="accent1"/>
+          </a:lnRef>
+          <a:fillRef idx="3">
+            <a:schemeClr val="accent1"/>
+          </a:fillRef>
+          <a:effectRef idx="2">
+            <a:schemeClr val="accent1"/>
+          </a:effectRef>
+          <a:fontRef idx="minor">
+            <a:schemeClr val="lt1"/>
+          </a:fontRef>
+        </p:style>
+        <p:txBody>
+          <a:bodyPr rtlCol="0" anchor="ctr"/>
+          <a:lstStyle/>
+          <a:p>
+            <a:pPr algn="ctr"/>
+          </a:p>
+        </p:txBody>
+      </p:sp>
+      <p:pic>
+        <p:nvPicPr>
+          <p:cNvPr id="13" name="Picture 12" descr="image3.jpeg"/>
+          <p:cNvPicPr>
+            <a:picLocks noChangeAspect="1"/>
+          </p:cNvPicPr>
+          <p:nvPr/>
+        </p:nvPicPr>
+        <p:blipFill>
+          <a:blip r:embed="rId4"/>
+          <a:stretch>
+            <a:fillRect/>
+          </a:stretch>
+        </p:blipFill>
+        <p:spPr>
+          <a:xfrm>
+            <a:off x="4073190" y="950976"/>
+            <a:ext cx="2405795" cy="1938528"/>
+          </a:xfrm>
+          <a:prstGeom prst="rect">
+            <a:avLst/>
+          </a:prstGeom>
+          <a:ln w="9525">
+            <a:solidFill>
+              <a:srgbClr val="8EA9DB"/>
+            </a:solidFill>
+          </a:ln>
+        </p:spPr>
+      </p:pic>
+      <p:sp>
+        <p:nvSpPr>
+          <p:cNvPr id="14" name="Oval 13"/>
+          <p:cNvSpPr/>
+          <p:nvPr/>
+        </p:nvSpPr>
+        <p:spPr>
+          <a:xfrm>
+            <a:off x="3840479" y="3035808"/>
+            <a:ext cx="274320" cy="274320"/>
+          </a:xfrm>
+          <a:prstGeom prst="ellipse">
+            <a:avLst/>
+          </a:prstGeom>
+          <a:solidFill>
+            <a:srgbClr val="366092"/>
+          </a:solidFill>
+          <a:ln>
+            <a:noFill/>
+          </a:ln>
+          <a:effectLst/>
+        </p:spPr>
+        <p:style>
+          <a:lnRef idx="1">
+            <a:schemeClr val="accent1"/>
+          </a:lnRef>
+          <a:fillRef idx="3">
+            <a:schemeClr val="accent1"/>
+          </a:fillRef>
+          <a:effectRef idx="2">
+            <a:schemeClr val="accent1"/>
+          </a:effectRef>
+          <a:fontRef idx="minor">
+            <a:schemeClr val="lt1"/>
+          </a:fontRef>
+        </p:style>
+        <p:txBody>
+          <a:bodyPr rtlCol="0" anchor="ctr" wrap="none"/>
+          <a:lstStyle/>
+          <a:p>
+            <a:pPr algn="ctr"/>
+            <a:r>
+              <a:rPr sz="1200" b="1">
+                <a:solidFill>
+                  <a:srgbClr val="FFFFFF"/>
+                </a:solidFill>
+                <a:latin typeface="Calibri" panose="020F0502020204030204"/>
+                <a:ea typeface="微软雅黑" panose="020B0503020204020204" charset="-122"/>
+                <a:cs typeface="Calibri" panose="020F0502020204030204"/>
+              </a:rPr>
+              <a:t>2</a:t>
+            </a:r>
+          </a:p>
+        </p:txBody>
+      </p:sp>
+      <p:sp>
+        <p:nvSpPr>
+          <p:cNvPr id="15" name="TextBox 14"/>
+          <p:cNvSpPr txBox="1"/>
+          <p:nvPr/>
+        </p:nvSpPr>
+        <p:spPr>
+          <a:xfrm>
+            <a:off x="4187952" y="3017520"/>
+            <a:ext cx="1490472" cy="310896"/>
+          </a:xfrm>
+          <a:prstGeom prst="rect">
+            <a:avLst/>
+          </a:prstGeom>
+          <a:noFill/>
+        </p:spPr>
+        <p:txBody>
+          <a:bodyPr wrap="square" anchor="ctr" lIns="45720" rIns="45720" tIns="0" bIns="0">
+            <a:spAutoFit/>
+          </a:bodyPr>
+          <a:lstStyle/>
+          <a:p>
+            <a:pPr algn="l"/>
+            <a:r>
+              <a:rPr sz="1100" b="1">
+                <a:solidFill>
+                  <a:srgbClr val="366092"/>
+                </a:solidFill>
+                <a:latin typeface="Calibri" panose="020F0502020204030204"/>
+                <a:ea typeface="微软雅黑" panose="020B0503020204020204" charset="-122"/>
+                <a:cs typeface="Calibri" panose="020F0502020204030204"/>
+              </a:rPr>
+              <a:t>1211-HPPC03-AT04</a:t>
+            </a:r>
+          </a:p>
+        </p:txBody>
+      </p:sp>
+      <p:sp>
+        <p:nvSpPr>
+          <p:cNvPr id="16" name="Rounded Rectangle 15"/>
+          <p:cNvSpPr/>
+          <p:nvPr/>
+        </p:nvSpPr>
+        <p:spPr>
+          <a:xfrm>
+            <a:off x="5769864" y="3054096"/>
+            <a:ext cx="960120" cy="256032"/>
+          </a:xfrm>
+          <a:prstGeom prst="roundRect">
+            <a:avLst>
+              <a:gd name="adj" fmla="val 50000"/>
+            </a:avLst>
+          </a:prstGeom>
+          <a:solidFill>
+            <a:srgbClr val="C00000"/>
+          </a:solidFill>
+          <a:ln>
+            <a:noFill/>
+          </a:ln>
+          <a:effectLst/>
+        </p:spPr>
+        <p:style>
+          <a:lnRef idx="1">
+            <a:schemeClr val="accent1"/>
+          </a:lnRef>
+          <a:fillRef idx="3">
+            <a:schemeClr val="accent1"/>
+          </a:fillRef>
+          <a:effectRef idx="2">
+            <a:schemeClr val="accent1"/>
+          </a:effectRef>
+          <a:fontRef idx="minor">
+            <a:schemeClr val="lt1"/>
+          </a:fontRef>
+        </p:style>
+        <p:txBody>
+          <a:bodyPr rtlCol="0" anchor="ctr" wrap="none"/>
+          <a:lstStyle/>
+          <a:p>
+            <a:pPr algn="ctr"/>
+            <a:r>
+              <a:rPr sz="900" b="1">
+                <a:solidFill>
+                  <a:srgbClr val="FFFFFF"/>
+                </a:solidFill>
+                <a:latin typeface="Calibri" panose="020F0502020204030204"/>
+                <a:ea typeface="微软雅黑" panose="020B0503020204020204" charset="-122"/>
+                <a:cs typeface="Calibri" panose="020F0502020204030204"/>
+              </a:rPr>
+              <a:t>Not compliant</a:t>
+            </a:r>
+          </a:p>
+        </p:txBody>
+      </p:sp>
+      <p:sp>
+        <p:nvSpPr>
+          <p:cNvPr id="17" name="Rounded Rectangle 16"/>
+          <p:cNvSpPr/>
+          <p:nvPr/>
+        </p:nvSpPr>
+        <p:spPr>
+          <a:xfrm>
+            <a:off x="384048" y="3593592"/>
+            <a:ext cx="3127248" cy="2615184"/>
+          </a:xfrm>
+          <a:prstGeom prst="roundRect">
+            <a:avLst>
+              <a:gd name="adj" fmla="val 8000"/>
+            </a:avLst>
+          </a:prstGeom>
+          <a:solidFill>
+            <a:srgbClr val="F3F6FB"/>
+          </a:solidFill>
+          <a:ln w="9525">
+            <a:solidFill>
+              <a:srgbClr val="8EA9DB"/>
+            </a:solidFill>
+          </a:ln>
+          <a:effectLst/>
+        </p:spPr>
+        <p:style>
+          <a:lnRef idx="1">
+            <a:schemeClr val="accent1"/>
+          </a:lnRef>
+          <a:fillRef idx="3">
+            <a:schemeClr val="accent1"/>
+          </a:fillRef>
+          <a:effectRef idx="2">
+            <a:schemeClr val="accent1"/>
+          </a:effectRef>
+          <a:fontRef idx="minor">
+            <a:schemeClr val="lt1"/>
+          </a:fontRef>
+        </p:style>
+        <p:txBody>
+          <a:bodyPr rtlCol="0" anchor="ctr"/>
+          <a:lstStyle/>
+          <a:p>
+            <a:pPr algn="ctr"/>
+          </a:p>
+        </p:txBody>
+      </p:sp>
+      <p:pic>
+        <p:nvPicPr>
+          <p:cNvPr id="18" name="Picture 17" descr="image4.jpeg"/>
+          <p:cNvPicPr>
+            <a:picLocks noChangeAspect="1"/>
+          </p:cNvPicPr>
+          <p:nvPr/>
+        </p:nvPicPr>
+        <p:blipFill>
+          <a:blip r:embed="rId5"/>
+          <a:stretch>
+            <a:fillRect/>
+          </a:stretch>
+        </p:blipFill>
+        <p:spPr>
+          <a:xfrm>
+            <a:off x="612709" y="3703320"/>
+            <a:ext cx="2669925" cy="1938528"/>
+          </a:xfrm>
+          <a:prstGeom prst="rect">
+            <a:avLst/>
+          </a:prstGeom>
+          <a:ln w="9525">
+            <a:solidFill>
+              <a:srgbClr val="8EA9DB"/>
+            </a:solidFill>
+          </a:ln>
+        </p:spPr>
+      </p:pic>
+      <p:sp>
+        <p:nvSpPr>
+          <p:cNvPr id="19" name="Oval 18"/>
+          <p:cNvSpPr/>
+          <p:nvPr/>
+        </p:nvSpPr>
+        <p:spPr>
+          <a:xfrm>
+            <a:off x="512064" y="5788152"/>
+            <a:ext cx="274320" cy="274320"/>
+          </a:xfrm>
+          <a:prstGeom prst="ellipse">
+            <a:avLst/>
+          </a:prstGeom>
+          <a:solidFill>
+            <a:srgbClr val="366092"/>
+          </a:solidFill>
+          <a:ln>
+            <a:noFill/>
+          </a:ln>
+          <a:effectLst/>
+        </p:spPr>
+        <p:style>
+          <a:lnRef idx="1">
+            <a:schemeClr val="accent1"/>
+          </a:lnRef>
+          <a:fillRef idx="3">
+            <a:schemeClr val="accent1"/>
+          </a:fillRef>
+          <a:effectRef idx="2">
+            <a:schemeClr val="accent1"/>
+          </a:effectRef>
+          <a:fontRef idx="minor">
+            <a:schemeClr val="lt1"/>
+          </a:fontRef>
+        </p:style>
+        <p:txBody>
+          <a:bodyPr rtlCol="0" anchor="ctr" wrap="none"/>
+          <a:lstStyle/>
+          <a:p>
+            <a:pPr algn="ctr"/>
+            <a:r>
+              <a:rPr sz="1200" b="1">
+                <a:solidFill>
+                  <a:srgbClr val="FFFFFF"/>
+                </a:solidFill>
+                <a:latin typeface="Calibri" panose="020F0502020204030204"/>
+                <a:ea typeface="微软雅黑" panose="020B0503020204020204" charset="-122"/>
+                <a:cs typeface="Calibri" panose="020F0502020204030204"/>
+              </a:rPr>
+              <a:t>3</a:t>
+            </a:r>
+          </a:p>
+        </p:txBody>
+      </p:sp>
+      <p:sp>
+        <p:nvSpPr>
+          <p:cNvPr id="20" name="TextBox 19"/>
+          <p:cNvSpPr txBox="1"/>
+          <p:nvPr/>
+        </p:nvSpPr>
+        <p:spPr>
+          <a:xfrm>
+            <a:off x="859536" y="5769864"/>
+            <a:ext cx="1490472" cy="310896"/>
+          </a:xfrm>
+          <a:prstGeom prst="rect">
+            <a:avLst/>
+          </a:prstGeom>
+          <a:noFill/>
+        </p:spPr>
+        <p:txBody>
+          <a:bodyPr wrap="square" anchor="ctr" lIns="45720" rIns="45720" tIns="0" bIns="0">
+            <a:spAutoFit/>
+          </a:bodyPr>
+          <a:lstStyle/>
+          <a:p>
+            <a:pPr algn="l"/>
+            <a:r>
+              <a:rPr sz="1100" b="1">
+                <a:solidFill>
+                  <a:srgbClr val="366092"/>
+                </a:solidFill>
+                <a:latin typeface="Calibri" panose="020F0502020204030204"/>
+                <a:ea typeface="微软雅黑" panose="020B0503020204020204" charset="-122"/>
+                <a:cs typeface="Calibri" panose="020F0502020204030204"/>
+              </a:rPr>
+              <a:t>1211-HPPC03-AT05</a:t>
+            </a:r>
+          </a:p>
+        </p:txBody>
+      </p:sp>
+      <p:sp>
+        <p:nvSpPr>
+          <p:cNvPr id="21" name="Rounded Rectangle 20"/>
+          <p:cNvSpPr/>
+          <p:nvPr/>
+        </p:nvSpPr>
+        <p:spPr>
+          <a:xfrm>
+            <a:off x="2441448" y="5806440"/>
+            <a:ext cx="960120" cy="256032"/>
+          </a:xfrm>
+          <a:prstGeom prst="roundRect">
+            <a:avLst>
+              <a:gd name="adj" fmla="val 50000"/>
+            </a:avLst>
+          </a:prstGeom>
+          <a:solidFill>
+            <a:srgbClr val="2E7D32"/>
+          </a:solidFill>
+          <a:ln>
+            <a:noFill/>
+          </a:ln>
+          <a:effectLst/>
+        </p:spPr>
+        <p:style>
+          <a:lnRef idx="1">
+            <a:schemeClr val="accent1"/>
+          </a:lnRef>
+          <a:fillRef idx="3">
+            <a:schemeClr val="accent1"/>
+          </a:fillRef>
+          <a:effectRef idx="2">
+            <a:schemeClr val="accent1"/>
+          </a:effectRef>
+          <a:fontRef idx="minor">
+            <a:schemeClr val="lt1"/>
+          </a:fontRef>
+        </p:style>
+        <p:txBody>
+          <a:bodyPr rtlCol="0" anchor="ctr" wrap="none"/>
+          <a:lstStyle/>
+          <a:p>
+            <a:pPr algn="ctr"/>
+            <a:r>
+              <a:rPr sz="900" b="1">
+                <a:solidFill>
+                  <a:srgbClr val="FFFFFF"/>
+                </a:solidFill>
+                <a:latin typeface="Calibri" panose="020F0502020204030204"/>
+                <a:ea typeface="微软雅黑" panose="020B0503020204020204" charset="-122"/>
+                <a:cs typeface="Calibri" panose="020F0502020204030204"/>
+              </a:rPr>
+              <a:t>Compliant</a:t>
+            </a:r>
+          </a:p>
+        </p:txBody>
+      </p:sp>
+      <p:sp>
+        <p:nvSpPr>
+          <p:cNvPr id="22" name="Rounded Rectangle 21"/>
+          <p:cNvSpPr/>
+          <p:nvPr/>
+        </p:nvSpPr>
+        <p:spPr>
+          <a:xfrm>
+            <a:off x="3712463" y="3593592"/>
+            <a:ext cx="3127248" cy="2615184"/>
+          </a:xfrm>
+          <a:prstGeom prst="roundRect">
+            <a:avLst>
+              <a:gd name="adj" fmla="val 8000"/>
+            </a:avLst>
+          </a:prstGeom>
+          <a:solidFill>
+            <a:srgbClr val="F3F6FB"/>
+          </a:solidFill>
+          <a:ln w="9525">
+            <a:solidFill>
+              <a:srgbClr val="8EA9DB"/>
+            </a:solidFill>
+          </a:ln>
+          <a:effectLst/>
+        </p:spPr>
+        <p:style>
+          <a:lnRef idx="1">
+            <a:schemeClr val="accent1"/>
+          </a:lnRef>
+          <a:fillRef idx="3">
+            <a:schemeClr val="accent1"/>
+          </a:fillRef>
+          <a:effectRef idx="2">
+            <a:schemeClr val="accent1"/>
+          </a:effectRef>
+          <a:fontRef idx="minor">
+            <a:schemeClr val="lt1"/>
+          </a:fontRef>
+        </p:style>
+        <p:txBody>
+          <a:bodyPr rtlCol="0" anchor="ctr"/>
+          <a:lstStyle/>
+          <a:p>
+            <a:pPr algn="ctr"/>
+          </a:p>
+        </p:txBody>
+      </p:sp>
+      <p:pic>
+        <p:nvPicPr>
+          <p:cNvPr id="23" name="Picture 22" descr="image5.jpeg"/>
+          <p:cNvPicPr>
+            <a:picLocks noChangeAspect="1"/>
+          </p:cNvPicPr>
+          <p:nvPr/>
+        </p:nvPicPr>
+        <p:blipFill>
+          <a:blip r:embed="rId6"/>
+          <a:stretch>
+            <a:fillRect/>
+          </a:stretch>
+        </p:blipFill>
+        <p:spPr>
+          <a:xfrm>
+            <a:off x="4049212" y="3703320"/>
+            <a:ext cx="2453751" cy="1938528"/>
+          </a:xfrm>
+          <a:prstGeom prst="rect">
+            <a:avLst/>
+          </a:prstGeom>
+          <a:ln w="9525">
+            <a:solidFill>
+              <a:srgbClr val="8EA9DB"/>
+            </a:solidFill>
+          </a:ln>
+        </p:spPr>
+      </p:pic>
+      <p:sp>
+        <p:nvSpPr>
+          <p:cNvPr id="24" name="Oval 23"/>
+          <p:cNvSpPr/>
+          <p:nvPr/>
+        </p:nvSpPr>
+        <p:spPr>
+          <a:xfrm>
+            <a:off x="3840479" y="5788152"/>
+            <a:ext cx="274320" cy="274320"/>
+          </a:xfrm>
+          <a:prstGeom prst="ellipse">
+            <a:avLst/>
+          </a:prstGeom>
+          <a:solidFill>
+            <a:srgbClr val="366092"/>
+          </a:solidFill>
+          <a:ln>
+            <a:noFill/>
+          </a:ln>
+          <a:effectLst/>
+        </p:spPr>
+        <p:style>
+          <a:lnRef idx="1">
+            <a:schemeClr val="accent1"/>
+          </a:lnRef>
+          <a:fillRef idx="3">
+            <a:schemeClr val="accent1"/>
+          </a:fillRef>
+          <a:effectRef idx="2">
+            <a:schemeClr val="accent1"/>
+          </a:effectRef>
+          <a:fontRef idx="minor">
+            <a:schemeClr val="lt1"/>
+          </a:fontRef>
+        </p:style>
+        <p:txBody>
+          <a:bodyPr rtlCol="0" anchor="ctr" wrap="none"/>
+          <a:lstStyle/>
+          <a:p>
+            <a:pPr algn="ctr"/>
+            <a:r>
+              <a:rPr sz="1200" b="1">
+                <a:solidFill>
+                  <a:srgbClr val="FFFFFF"/>
+                </a:solidFill>
+                <a:latin typeface="Calibri" panose="020F0502020204030204"/>
+                <a:ea typeface="微软雅黑" panose="020B0503020204020204" charset="-122"/>
+                <a:cs typeface="Calibri" panose="020F0502020204030204"/>
+              </a:rPr>
+              <a:t>4</a:t>
+            </a:r>
+          </a:p>
+        </p:txBody>
+      </p:sp>
+      <p:sp>
+        <p:nvSpPr>
+          <p:cNvPr id="25" name="TextBox 24"/>
+          <p:cNvSpPr txBox="1"/>
+          <p:nvPr/>
+        </p:nvSpPr>
+        <p:spPr>
+          <a:xfrm>
+            <a:off x="4187952" y="5769864"/>
+            <a:ext cx="1490472" cy="310896"/>
+          </a:xfrm>
+          <a:prstGeom prst="rect">
+            <a:avLst/>
+          </a:prstGeom>
+          <a:noFill/>
+        </p:spPr>
+        <p:txBody>
+          <a:bodyPr wrap="square" anchor="ctr" lIns="45720" rIns="45720" tIns="0" bIns="0">
+            <a:spAutoFit/>
+          </a:bodyPr>
+          <a:lstStyle/>
+          <a:p>
+            <a:pPr algn="l"/>
+            <a:r>
+              <a:rPr sz="1100" b="1">
+                <a:solidFill>
+                  <a:srgbClr val="366092"/>
+                </a:solidFill>
+                <a:latin typeface="Calibri" panose="020F0502020204030204"/>
+                <a:ea typeface="微软雅黑" panose="020B0503020204020204" charset="-122"/>
+                <a:cs typeface="Calibri" panose="020F0502020204030204"/>
+              </a:rPr>
+              <a:t>1211-HPPC03-AT06</a:t>
+            </a:r>
+          </a:p>
+        </p:txBody>
+      </p:sp>
+      <p:sp>
+        <p:nvSpPr>
+          <p:cNvPr id="26" name="Rounded Rectangle 25"/>
+          <p:cNvSpPr/>
+          <p:nvPr/>
+        </p:nvSpPr>
+        <p:spPr>
+          <a:xfrm>
+            <a:off x="5769864" y="5806440"/>
+            <a:ext cx="960120" cy="256032"/>
+          </a:xfrm>
+          <a:prstGeom prst="roundRect">
+            <a:avLst>
+              <a:gd name="adj" fmla="val 50000"/>
+            </a:avLst>
+          </a:prstGeom>
+          <a:solidFill>
+            <a:srgbClr val="2E7D32"/>
+          </a:solidFill>
+          <a:ln>
+            <a:noFill/>
+          </a:ln>
+          <a:effectLst/>
+        </p:spPr>
+        <p:style>
+          <a:lnRef idx="1">
+            <a:schemeClr val="accent1"/>
+          </a:lnRef>
+          <a:fillRef idx="3">
+            <a:schemeClr val="accent1"/>
+          </a:fillRef>
+          <a:effectRef idx="2">
+            <a:schemeClr val="accent1"/>
+          </a:effectRef>
+          <a:fontRef idx="minor">
+            <a:schemeClr val="lt1"/>
+          </a:fontRef>
+        </p:style>
+        <p:txBody>
+          <a:bodyPr rtlCol="0" anchor="ctr" wrap="none"/>
+          <a:lstStyle/>
+          <a:p>
+            <a:pPr algn="ctr"/>
+            <a:r>
+              <a:rPr sz="900" b="1">
+                <a:solidFill>
+                  <a:srgbClr val="FFFFFF"/>
+                </a:solidFill>
+                <a:latin typeface="Calibri" panose="020F0502020204030204"/>
+                <a:ea typeface="微软雅黑" panose="020B0503020204020204" charset="-122"/>
+                <a:cs typeface="Calibri" panose="020F0502020204030204"/>
+              </a:rPr>
+              <a:t>Compliant</a:t>
+            </a:r>
+          </a:p>
+        </p:txBody>
+      </p:sp>
+      <p:sp>
+        <p:nvSpPr>
+          <p:cNvPr id="27" name="TextBox 26"/>
+          <p:cNvSpPr txBox="1"/>
+          <p:nvPr/>
+        </p:nvSpPr>
+        <p:spPr>
+          <a:xfrm>
+            <a:off x="7040880" y="832104"/>
+            <a:ext cx="4764024" cy="338328"/>
+          </a:xfrm>
+          <a:prstGeom prst="rect">
+            <a:avLst/>
+          </a:prstGeom>
+          <a:noFill/>
+        </p:spPr>
+        <p:txBody>
+          <a:bodyPr wrap="square" anchor="t" lIns="45720" rIns="45720" tIns="0" bIns="0">
+            <a:spAutoFit/>
+          </a:bodyPr>
+          <a:lstStyle/>
+          <a:p>
+            <a:pPr algn="l"/>
+            <a:r>
+              <a:rPr sz="1600" b="1">
+                <a:solidFill>
+                  <a:srgbClr val="366092"/>
+                </a:solidFill>
+                <a:latin typeface="Calibri" panose="020F0502020204030204"/>
+                <a:ea typeface="微软雅黑" panose="020B0503020204020204" charset="-122"/>
+                <a:cs typeface="Calibri" panose="020F0502020204030204"/>
+              </a:rPr>
+              <a:t>Check result</a:t>
+            </a:r>
+          </a:p>
+        </p:txBody>
+      </p:sp>
+      <p:graphicFrame>
+        <p:nvGraphicFramePr>
+          <p:cNvPr id="28" name="Table 27"/>
+          <p:cNvGraphicFramePr>
+            <a:graphicFrameLocks noGrp="1"/>
+          </p:cNvGraphicFramePr>
+          <p:nvPr/>
+        </p:nvGraphicFramePr>
+        <p:xfrm>
+          <a:off x="7040880" y="1298448"/>
+          <a:ext cx="4764023" cy="1463040"/>
+        </p:xfrm>
+        <a:graphic>
+          <a:graphicData uri="http://schemas.openxmlformats.org/drawingml/2006/table">
+            <a:tbl>
+              <a:tblPr firstRow="1" bandRow="1">
+                <a:tableStyleId>{5C22544A-7EE6-4342-B048-85BDC9FD1C3A}</a:tableStyleId>
+              </a:tblPr>
+              <a:tblGrid>
+                <a:gridCol w="2191451"/>
+                <a:gridCol w="2572572"/>
+              </a:tblGrid>
+              <a:tr h="292608">
+                <a:tc>
+                  <a:txBody>
+                    <a:bodyPr/>
+                    <a:lstStyle/>
+                    <a:p>
+                      <a:pPr algn="l"/>
+                      <a:r>
+                        <a:rPr sz="1200" b="1">
+                          <a:solidFill>
+                            <a:srgbClr val="FFFFFF"/>
+                          </a:solidFill>
+                          <a:latin typeface="Calibri" panose="020F0502020204030204"/>
+                          <a:ea typeface="微软雅黑" panose="020B0503020204020204" charset="-122"/>
+                          <a:cs typeface="Calibri" panose="020F0502020204030204"/>
+                        </a:rPr>
+                        <a:t>Component receiving tank</a:t>
+                      </a:r>
+                    </a:p>
+                  </a:txBody>
+                  <a:tcPr anchor="ctr" marL="73152" marR="73152" marT="0" marB="0">
+                    <a:solidFill>
+                      <a:srgbClr val="366092"/>
+                    </a:solidFill>
+                  </a:tcPr>
+                </a:tc>
+                <a:tc>
+                  <a:txBody>
+                    <a:bodyPr/>
+                    <a:lstStyle/>
+                    <a:p>
+                      <a:pPr algn="l"/>
+                      <a:r>
+                        <a:rPr sz="1200" b="1">
+                          <a:solidFill>
+                            <a:srgbClr val="FFFFFF"/>
+                          </a:solidFill>
+                          <a:latin typeface="Calibri" panose="020F0502020204030204"/>
+                          <a:ea typeface="微软雅黑" panose="020B0503020204020204" charset="-122"/>
+                          <a:cs typeface="Calibri" panose="020F0502020204030204"/>
+                        </a:rPr>
+                        <a:t>Agitation check</a:t>
+                      </a:r>
+                    </a:p>
+                  </a:txBody>
+                  <a:tcPr anchor="ctr" marL="73152" marR="73152" marT="0" marB="0">
+                    <a:solidFill>
+                      <a:srgbClr val="366092"/>
+                    </a:solidFill>
+                  </a:tcPr>
+                </a:tc>
+              </a:tr>
+              <a:tr h="292608">
+                <a:tc>
+                  <a:txBody>
+                    <a:bodyPr/>
+                    <a:lstStyle/>
+                    <a:p>
+                      <a:pPr algn="l"/>
+                      <a:r>
+                        <a:rPr sz="1200" b="0">
+                          <a:solidFill>
+                            <a:srgbClr val="222222"/>
+                          </a:solidFill>
+                          <a:latin typeface="Calibri" panose="020F0502020204030204"/>
+                          <a:ea typeface="微软雅黑" panose="020B0503020204020204" charset="-122"/>
+                          <a:cs typeface="Calibri" panose="020F0502020204030204"/>
+                        </a:rPr>
+                        <a:t>1211-HPPC03-AT03</a:t>
+                      </a:r>
+                    </a:p>
+                  </a:txBody>
+                  <a:tcPr anchor="ctr" marL="73152" marR="73152" marT="0" marB="0">
+                    <a:solidFill>
+                      <a:srgbClr val="FFFFFF"/>
+                    </a:solidFill>
+                  </a:tcPr>
+                </a:tc>
+                <a:tc>
+                  <a:txBody>
+                    <a:bodyPr/>
+                    <a:lstStyle/>
+                    <a:p>
+                      <a:pPr algn="l"/>
+                      <a:r>
+                        <a:rPr sz="1200" b="0">
+                          <a:solidFill>
+                            <a:srgbClr val="222222"/>
+                          </a:solidFill>
+                          <a:latin typeface="Calibri" panose="020F0502020204030204"/>
+                          <a:ea typeface="微软雅黑" panose="020B0503020204020204" charset="-122"/>
+                          <a:cs typeface="Calibri" panose="020F0502020204030204"/>
+                        </a:rPr>
+                        <a:t>Meets requirement</a:t>
+                      </a:r>
+                    </a:p>
+                  </a:txBody>
+                  <a:tcPr anchor="ctr" marL="73152" marR="73152" marT="0" marB="0">
+                    <a:solidFill>
+                      <a:srgbClr val="FFFFFF"/>
+                    </a:solidFill>
+                  </a:tcPr>
+                </a:tc>
+              </a:tr>
+              <a:tr h="292608">
+                <a:tc>
+                  <a:txBody>
+                    <a:bodyPr/>
+                    <a:lstStyle/>
+                    <a:p>
+                      <a:pPr algn="l"/>
+                      <a:r>
+                        <a:rPr sz="1200" b="0">
+                          <a:solidFill>
+                            <a:srgbClr val="222222"/>
+                          </a:solidFill>
+                          <a:latin typeface="Calibri" panose="020F0502020204030204"/>
+                          <a:ea typeface="微软雅黑" panose="020B0503020204020204" charset="-122"/>
+                          <a:cs typeface="Calibri" panose="020F0502020204030204"/>
+                        </a:rPr>
+                        <a:t>1211-HPPC03-AT04</a:t>
+                      </a:r>
+                    </a:p>
+                  </a:txBody>
+                  <a:tcPr anchor="ctr" marL="73152" marR="73152" marT="0" marB="0">
+                    <a:solidFill>
+                      <a:srgbClr val="F3F6FB"/>
+                    </a:solidFill>
+                  </a:tcPr>
+                </a:tc>
+                <a:tc>
+                  <a:txBody>
+                    <a:bodyPr/>
+                    <a:lstStyle/>
+                    <a:p>
+                      <a:pPr algn="l"/>
+                      <a:r>
+                        <a:rPr sz="1200" b="1">
+                          <a:solidFill>
+                            <a:srgbClr val="C00000"/>
+                          </a:solidFill>
+                          <a:latin typeface="Calibri" panose="020F0502020204030204"/>
+                          <a:ea typeface="微软雅黑" panose="020B0503020204020204" charset="-122"/>
+                          <a:cs typeface="Calibri" panose="020F0502020204030204"/>
+                        </a:rPr>
+                        <a:t>Does not meet requirement</a:t>
+                      </a:r>
+                    </a:p>
+                  </a:txBody>
+                  <a:tcPr anchor="ctr" marL="73152" marR="73152" marT="0" marB="0">
+                    <a:solidFill>
+                      <a:srgbClr val="F3F6FB"/>
+                    </a:solidFill>
+                  </a:tcPr>
+                </a:tc>
+              </a:tr>
+              <a:tr h="292608">
+                <a:tc>
+                  <a:txBody>
+                    <a:bodyPr/>
+                    <a:lstStyle/>
+                    <a:p>
+                      <a:pPr algn="l"/>
+                      <a:r>
+                        <a:rPr sz="1200" b="0">
+                          <a:solidFill>
+                            <a:srgbClr val="222222"/>
+                          </a:solidFill>
+                          <a:latin typeface="Calibri" panose="020F0502020204030204"/>
+                          <a:ea typeface="微软雅黑" panose="020B0503020204020204" charset="-122"/>
+                          <a:cs typeface="Calibri" panose="020F0502020204030204"/>
+                        </a:rPr>
+                        <a:t>1211-HPPC03-AT05</a:t>
+                      </a:r>
+                    </a:p>
+                  </a:txBody>
+                  <a:tcPr anchor="ctr" marL="73152" marR="73152" marT="0" marB="0">
+                    <a:solidFill>
+                      <a:srgbClr val="FFFFFF"/>
+                    </a:solidFill>
+                  </a:tcPr>
+                </a:tc>
+                <a:tc>
+                  <a:txBody>
+                    <a:bodyPr/>
+                    <a:lstStyle/>
+                    <a:p>
+                      <a:pPr algn="l"/>
+                      <a:r>
+                        <a:rPr sz="1200" b="0">
+                          <a:solidFill>
+                            <a:srgbClr val="222222"/>
+                          </a:solidFill>
+                          <a:latin typeface="Calibri" panose="020F0502020204030204"/>
+                          <a:ea typeface="微软雅黑" panose="020B0503020204020204" charset="-122"/>
+                          <a:cs typeface="Calibri" panose="020F0502020204030204"/>
+                        </a:rPr>
+                        <a:t>Meets requirement</a:t>
+                      </a:r>
+                    </a:p>
+                  </a:txBody>
+                  <a:tcPr anchor="ctr" marL="73152" marR="73152" marT="0" marB="0">
+                    <a:solidFill>
+                      <a:srgbClr val="FFFFFF"/>
+                    </a:solidFill>
+                  </a:tcPr>
+                </a:tc>
+              </a:tr>
+              <a:tr h="292608">
+                <a:tc>
+                  <a:txBody>
+                    <a:bodyPr/>
+                    <a:lstStyle/>
+                    <a:p>
+                      <a:pPr algn="l"/>
+                      <a:r>
+                        <a:rPr sz="1200" b="0">
+                          <a:solidFill>
+                            <a:srgbClr val="222222"/>
+                          </a:solidFill>
+                          <a:latin typeface="Calibri" panose="020F0502020204030204"/>
+                          <a:ea typeface="微软雅黑" panose="020B0503020204020204" charset="-122"/>
+                          <a:cs typeface="Calibri" panose="020F0502020204030204"/>
+                        </a:rPr>
+                        <a:t>1211-HPPC03-AT06</a:t>
+                      </a:r>
+                    </a:p>
+                  </a:txBody>
+                  <a:tcPr anchor="ctr" marL="73152" marR="73152" marT="0" marB="0">
+                    <a:solidFill>
+                      <a:srgbClr val="F3F6FB"/>
+                    </a:solidFill>
+                  </a:tcPr>
+                </a:tc>
+                <a:tc>
+                  <a:txBody>
+                    <a:bodyPr/>
+                    <a:lstStyle/>
+                    <a:p>
+                      <a:pPr algn="l"/>
+                      <a:r>
+                        <a:rPr sz="1200" b="0">
+                          <a:solidFill>
+                            <a:srgbClr val="222222"/>
+                          </a:solidFill>
+                          <a:latin typeface="Calibri" panose="020F0502020204030204"/>
+                          <a:ea typeface="微软雅黑" panose="020B0503020204020204" charset="-122"/>
+                          <a:cs typeface="Calibri" panose="020F0502020204030204"/>
+                        </a:rPr>
+                        <a:t>Meets requirement</a:t>
+                      </a:r>
+                    </a:p>
+                  </a:txBody>
+                  <a:tcPr anchor="ctr" marL="73152" marR="73152" marT="0" marB="0">
+                    <a:solidFill>
+                      <a:srgbClr val="F3F6FB"/>
+                    </a:solidFill>
+                  </a:tcPr>
+                </a:tc>
+              </a:tr>
+            </a:tbl>
+          </a:graphicData>
+        </a:graphic>
+      </p:graphicFrame>
+      <p:sp>
+        <p:nvSpPr>
+          <p:cNvPr id="29" name="Rounded Rectangle 28"/>
+          <p:cNvSpPr/>
+          <p:nvPr/>
+        </p:nvSpPr>
+        <p:spPr>
+          <a:xfrm>
+            <a:off x="7040880" y="2926080"/>
+            <a:ext cx="4764024" cy="1508760"/>
+          </a:xfrm>
+          <a:prstGeom prst="roundRect">
+            <a:avLst>
+              <a:gd name="adj" fmla="val 8000"/>
+            </a:avLst>
+          </a:prstGeom>
+          <a:solidFill>
+            <a:srgbClr val="F3F6FB"/>
+          </a:solidFill>
+          <a:ln w="9525">
+            <a:solidFill>
+              <a:srgbClr val="8EA9DB"/>
+            </a:solidFill>
+          </a:ln>
+          <a:effectLst/>
+        </p:spPr>
+        <p:style>
+          <a:lnRef idx="1">
+            <a:schemeClr val="accent1"/>
+          </a:lnRef>
+          <a:fillRef idx="3">
+            <a:schemeClr val="accent1"/>
+          </a:fillRef>
+          <a:effectRef idx="2">
+            <a:schemeClr val="accent1"/>
+          </a:effectRef>
+          <a:fontRef idx="minor">
+            <a:schemeClr val="lt1"/>
+          </a:fontRef>
+        </p:style>
+        <p:txBody>
+          <a:bodyPr rtlCol="0" anchor="ctr"/>
+          <a:lstStyle/>
+          <a:p>
+            <a:pPr algn="ctr"/>
+          </a:p>
+        </p:txBody>
+      </p:sp>
+      <p:sp>
+        <p:nvSpPr>
+          <p:cNvPr id="30" name="TextBox 29"/>
+          <p:cNvSpPr txBox="1"/>
+          <p:nvPr/>
+        </p:nvSpPr>
+        <p:spPr>
+          <a:xfrm>
+            <a:off x="7205472" y="3035808"/>
+            <a:ext cx="4434840" cy="310896"/>
+          </a:xfrm>
+          <a:prstGeom prst="rect">
+            <a:avLst/>
+          </a:prstGeom>
+          <a:noFill/>
+        </p:spPr>
+        <p:txBody>
+          <a:bodyPr wrap="square" anchor="t" lIns="45720" rIns="45720" tIns="0" bIns="0">
+            <a:spAutoFit/>
+          </a:bodyPr>
+          <a:lstStyle/>
+          <a:p>
+            <a:pPr algn="l"/>
+            <a:r>
+              <a:rPr sz="1400" b="1">
+                <a:solidFill>
+                  <a:srgbClr val="366092"/>
+                </a:solidFill>
+                <a:latin typeface="Calibri" panose="020F0502020204030204"/>
+                <a:ea typeface="微软雅黑" panose="020B0503020204020204" charset="-122"/>
+                <a:cs typeface="Calibri" panose="020F0502020204030204"/>
+              </a:rPr>
+              <a:t>Scope and method</a:t>
+            </a:r>
+          </a:p>
+        </p:txBody>
+      </p:sp>
+      <p:sp>
+        <p:nvSpPr>
+          <p:cNvPr id="31" name="TextBox 30"/>
+          <p:cNvSpPr txBox="1"/>
+          <p:nvPr/>
+        </p:nvSpPr>
+        <p:spPr>
+          <a:xfrm>
+            <a:off x="7205472" y="3383280"/>
+            <a:ext cx="4434840" cy="941831"/>
+          </a:xfrm>
+          <a:prstGeom prst="rect">
+            <a:avLst/>
+          </a:prstGeom>
+          <a:noFill/>
+        </p:spPr>
+        <p:txBody>
+          <a:bodyPr wrap="square" anchor="t" lIns="45720" rIns="45720" tIns="0" bIns="0">
+            <a:spAutoFit/>
+          </a:bodyPr>
+          <a:lstStyle/>
+          <a:p>
+            <a:pPr algn="l">
+              <a:spcAft>
+                <a:spcPts val="400"/>
+              </a:spcAft>
+            </a:pPr>
+            <a:r>
+              <a:rPr sz="1200" b="0">
+                <a:solidFill>
+                  <a:srgbClr val="222222"/>
+                </a:solidFill>
+                <a:latin typeface="Calibri" panose="020F0502020204030204"/>
+                <a:ea typeface="微软雅黑" panose="020B0503020204020204" charset="-122"/>
+                <a:cs typeface="Calibri" panose="020F0502020204030204"/>
+              </a:rPr>
+              <a:t>The four component receiving tanks of the preparation system were observed with the agitator running.</a:t>
+            </a:r>
+          </a:p>
+          <a:p>
+            <a:pPr algn="l">
+              <a:spcAft>
+                <a:spcPts val="400"/>
+              </a:spcAft>
+            </a:pPr>
+            <a:r>
+              <a:rPr sz="1200" b="0">
+                <a:solidFill>
+                  <a:srgbClr val="222222"/>
+                </a:solidFill>
+                <a:latin typeface="Calibri" panose="020F0502020204030204"/>
+                <a:ea typeface="微软雅黑" panose="020B0503020204020204" charset="-122"/>
+                <a:cs typeface="Calibri" panose="020F0502020204030204"/>
+              </a:rPr>
+              <a:t>Each tank was photographed through the manway (TJ4-GMP-067, 2026-09-16).</a:t>
+            </a:r>
+          </a:p>
+        </p:txBody>
+      </p:sp>
+      <p:sp>
+        <p:nvSpPr>
+          <p:cNvPr id="32" name="Rounded Rectangle 31"/>
+          <p:cNvSpPr/>
+          <p:nvPr/>
+        </p:nvSpPr>
+        <p:spPr>
+          <a:xfrm>
+            <a:off x="7040880" y="4617720"/>
+            <a:ext cx="4764024" cy="1591056"/>
+          </a:xfrm>
+          <a:prstGeom prst="roundRect">
+            <a:avLst>
+              <a:gd name="adj" fmla="val 8000"/>
+            </a:avLst>
+          </a:prstGeom>
+          <a:solidFill>
+            <a:srgbClr val="FDEDED"/>
+          </a:solidFill>
+          <a:ln w="9525">
+            <a:solidFill>
+              <a:srgbClr val="C00000"/>
+            </a:solidFill>
+          </a:ln>
+          <a:effectLst/>
+        </p:spPr>
+        <p:style>
+          <a:lnRef idx="1">
+            <a:schemeClr val="accent1"/>
+          </a:lnRef>
+          <a:fillRef idx="3">
+            <a:schemeClr val="accent1"/>
+          </a:fillRef>
+          <a:effectRef idx="2">
+            <a:schemeClr val="accent1"/>
+          </a:effectRef>
+          <a:fontRef idx="minor">
+            <a:schemeClr val="lt1"/>
+          </a:fontRef>
+        </p:style>
+        <p:txBody>
+          <a:bodyPr rtlCol="0" anchor="ctr"/>
+          <a:lstStyle/>
+          <a:p>
+            <a:pPr algn="ctr"/>
+          </a:p>
+        </p:txBody>
+      </p:sp>
+      <p:sp>
+        <p:nvSpPr>
+          <p:cNvPr id="33" name="TextBox 32"/>
+          <p:cNvSpPr txBox="1"/>
+          <p:nvPr/>
+        </p:nvSpPr>
+        <p:spPr>
+          <a:xfrm>
+            <a:off x="7205472" y="4727448"/>
+            <a:ext cx="4434840" cy="310896"/>
+          </a:xfrm>
+          <a:prstGeom prst="rect">
+            <a:avLst/>
+          </a:prstGeom>
+          <a:noFill/>
+        </p:spPr>
+        <p:txBody>
+          <a:bodyPr wrap="square" anchor="t" lIns="45720" rIns="45720" tIns="0" bIns="0">
+            <a:spAutoFit/>
+          </a:bodyPr>
+          <a:lstStyle/>
+          <a:p>
+            <a:pPr algn="l"/>
+            <a:r>
+              <a:rPr sz="1400" b="1">
+                <a:solidFill>
+                  <a:srgbClr val="C00000"/>
+                </a:solidFill>
+                <a:latin typeface="Calibri" panose="020F0502020204030204"/>
+                <a:ea typeface="微软雅黑" panose="020B0503020204020204" charset="-122"/>
+                <a:cs typeface="Calibri" panose="020F0502020204030204"/>
+              </a:rPr>
+              <a:t>Action before PPQ</a:t>
+            </a:r>
+          </a:p>
+        </p:txBody>
+      </p:sp>
+      <p:sp>
+        <p:nvSpPr>
+          <p:cNvPr id="34" name="TextBox 33"/>
+          <p:cNvSpPr txBox="1"/>
+          <p:nvPr/>
+        </p:nvSpPr>
+        <p:spPr>
+          <a:xfrm>
+            <a:off x="7205472" y="5074920"/>
+            <a:ext cx="4434840" cy="1024128"/>
+          </a:xfrm>
+          <a:prstGeom prst="rect">
+            <a:avLst/>
+          </a:prstGeom>
+          <a:noFill/>
+        </p:spPr>
+        <p:txBody>
+          <a:bodyPr wrap="square" anchor="t" lIns="45720" rIns="45720" tIns="0" bIns="0">
+            <a:spAutoFit/>
+          </a:bodyPr>
+          <a:lstStyle/>
+          <a:p>
+            <a:pPr algn="l">
+              <a:spcAft>
+                <a:spcPts val="400"/>
+              </a:spcAft>
+            </a:pPr>
+            <a:r>
+              <a:rPr sz="1200" b="0">
+                <a:solidFill>
+                  <a:srgbClr val="222222"/>
+                </a:solidFill>
+                <a:latin typeface="Calibri" panose="020F0502020204030204"/>
+                <a:ea typeface="微软雅黑" panose="020B0503020204020204" charset="-122"/>
+                <a:cs typeface="Calibri" panose="020F0502020204030204"/>
+              </a:rPr>
+              <a:t>3 of 4 tanks meet the agitation requirement.</a:t>
+            </a:r>
+          </a:p>
+          <a:p>
+            <a:pPr algn="l">
+              <a:spcAft>
+                <a:spcPts val="400"/>
+              </a:spcAft>
+            </a:pPr>
+            <a:r>
+              <a:rPr sz="1200" b="0">
+                <a:solidFill>
+                  <a:srgbClr val="222222"/>
+                </a:solidFill>
+                <a:latin typeface="Calibri" panose="020F0502020204030204"/>
+                <a:ea typeface="微软雅黑" panose="020B0503020204020204" charset="-122"/>
+                <a:cs typeface="Calibri" panose="020F0502020204030204"/>
+              </a:rPr>
+              <a:t>1211-HPPC03-AT04 does not meet the requirement.</a:t>
+            </a:r>
+          </a:p>
+          <a:p>
+            <a:pPr algn="l">
+              <a:spcAft>
+                <a:spcPts val="400"/>
+              </a:spcAft>
+            </a:pPr>
+            <a:r>
+              <a:rPr sz="1200" b="0">
+                <a:solidFill>
+                  <a:srgbClr val="222222"/>
+                </a:solidFill>
+                <a:latin typeface="Calibri" panose="020F0502020204030204"/>
+                <a:ea typeface="微软雅黑" panose="020B0503020204020204" charset="-122"/>
+                <a:cs typeface="Calibri" panose="020F0502020204030204"/>
+              </a:rPr>
+              <a:t>Rectification will be completed before PPQ.</a:t>
+            </a:r>
+          </a:p>
+        </p:txBody>
+      </p:sp>
+    </p:spTree>
+  </p:cSld>
+  <p:clrMapOvr>
+    <a:masterClrMapping/>
+  </p:clrMapOvr>
+</p:sld>
+</file>
+
+<file path=ppt/slides/slide7.xml><?xml version="1.0" encoding="utf-8"?>
+<p:sld xmlns:a="http://schemas.openxmlformats.org/drawingml/2006/main" xmlns:p="http://schemas.openxmlformats.org/presentationml/2006/main" xmlns:r="http://schemas.openxmlformats.org/officeDocument/2006/relationships">
+  <p:cSld>
+    <p:spTree>
+      <p:nvGrpSpPr>
+        <p:cNvPr id="1" name=""/>
+        <p:cNvGrpSpPr/>
+        <p:nvPr/>
+      </p:nvGrpSpPr>
+      <p:grpSpPr/>
+      <p:sp>
+        <p:nvSpPr>
+          <p:cNvPr id="2" name="Rectangle 1"/>
+          <p:cNvSpPr/>
+          <p:nvPr/>
+        </p:nvSpPr>
+        <p:spPr>
+          <a:xfrm>
+            <a:off x="0" y="658368"/>
+            <a:ext cx="12191695" cy="12700"/>
+          </a:xfrm>
+          <a:prstGeom prst="rect">
+            <a:avLst/>
+          </a:prstGeom>
+          <a:solidFill>
+            <a:srgbClr val="366092"/>
+          </a:solidFill>
+          <a:ln>
+            <a:noFill/>
+          </a:ln>
+          <a:effectLst/>
+        </p:spPr>
+        <p:style>
+          <a:lnRef idx="1">
+            <a:schemeClr val="accent1"/>
+          </a:lnRef>
+          <a:fillRef idx="3">
+            <a:schemeClr val="accent1"/>
+          </a:fillRef>
+          <a:effectRef idx="2">
+            <a:schemeClr val="accent1"/>
+          </a:effectRef>
+          <a:fontRef idx="minor">
+            <a:schemeClr val="lt1"/>
+          </a:fontRef>
+        </p:style>
+        <p:txBody>
+          <a:bodyPr rtlCol="0" anchor="ctr"/>
+          <a:lstStyle/>
+          <a:p>
+            <a:pPr algn="ctr"/>
+          </a:p>
+        </p:txBody>
+      </p:sp>
+      <p:pic>
+        <p:nvPicPr>
+          <p:cNvPr id="3" name="Picture 2" descr="image.png"/>
+          <p:cNvPicPr>
+            <a:picLocks noChangeAspect="1"/>
+          </p:cNvPicPr>
+          <p:nvPr/>
+        </p:nvPicPr>
+        <p:blipFill>
+          <a:blip r:embed="rId2"/>
+          <a:stretch>
+            <a:fillRect/>
+          </a:stretch>
+        </p:blipFill>
+        <p:spPr>
+          <a:xfrm>
+            <a:off x="347472" y="146304"/>
+            <a:ext cx="1933042" cy="384048"/>
+          </a:xfrm>
+          <a:prstGeom prst="rect">
+            <a:avLst/>
+          </a:prstGeom>
+        </p:spPr>
+      </p:pic>
+      <p:sp>
+        <p:nvSpPr>
+          <p:cNvPr id="4" name="TextBox 3"/>
+          <p:cNvSpPr txBox="1"/>
+          <p:nvPr/>
+        </p:nvSpPr>
+        <p:spPr>
+          <a:xfrm>
+            <a:off x="3749039" y="146304"/>
+            <a:ext cx="8046720" cy="438912"/>
+          </a:xfrm>
+          <a:prstGeom prst="rect">
+            <a:avLst/>
+          </a:prstGeom>
+          <a:noFill/>
+        </p:spPr>
+        <p:txBody>
+          <a:bodyPr wrap="square" anchor="t" lIns="45720" rIns="45720" tIns="0" bIns="0">
+            <a:spAutoFit/>
+          </a:bodyPr>
+          <a:lstStyle/>
+          <a:p>
+            <a:pPr algn="r"/>
+            <a:r>
+              <a:rPr sz="2200" b="1">
+                <a:solidFill>
+                  <a:srgbClr val="366092"/>
+                </a:solidFill>
+                <a:latin typeface="Calibri" panose="020F0502020204030204"/>
+                <a:ea typeface="微软雅黑" panose="020B0503020204020204" charset="-122"/>
+                <a:cs typeface="Calibri" panose="020F0502020204030204"/>
+              </a:rPr>
+              <a:t>1211-HPPC03-AT04: finding and action</a:t>
+            </a:r>
+          </a:p>
+        </p:txBody>
+      </p:sp>
+      <p:sp>
+        <p:nvSpPr>
+          <p:cNvPr id="5" name="Rectangle 4"/>
+          <p:cNvSpPr/>
+          <p:nvPr/>
+        </p:nvSpPr>
+        <p:spPr>
+          <a:xfrm>
+            <a:off x="0" y="6565392"/>
+            <a:ext cx="12191695" cy="292608"/>
+          </a:xfrm>
+          <a:prstGeom prst="rect">
+            <a:avLst/>
+          </a:prstGeom>
+          <a:solidFill>
+            <a:srgbClr val="1F4E79"/>
+          </a:solidFill>
+          <a:ln>
+            <a:noFill/>
+          </a:ln>
+          <a:effectLst/>
+        </p:spPr>
+        <p:style>
+          <a:lnRef idx="1">
+            <a:schemeClr val="accent1"/>
+          </a:lnRef>
+          <a:fillRef idx="3">
+            <a:schemeClr val="accent1"/>
+          </a:fillRef>
+          <a:effectRef idx="2">
+            <a:schemeClr val="accent1"/>
+          </a:effectRef>
+          <a:fontRef idx="minor">
+            <a:schemeClr val="lt1"/>
+          </a:fontRef>
+        </p:style>
+        <p:txBody>
+          <a:bodyPr rtlCol="0" anchor="ctr"/>
+          <a:lstStyle/>
+          <a:p>
+            <a:pPr algn="ctr"/>
+          </a:p>
+        </p:txBody>
+      </p:sp>
+      <p:sp>
+        <p:nvSpPr>
+          <p:cNvPr id="6" name="TextBox 5"/>
+          <p:cNvSpPr txBox="1"/>
+          <p:nvPr/>
+        </p:nvSpPr>
+        <p:spPr>
+          <a:xfrm>
+            <a:off x="365760" y="6583680"/>
+            <a:ext cx="11430000" cy="237744"/>
+          </a:xfrm>
+          <a:prstGeom prst="rect">
+            <a:avLst/>
+          </a:prstGeom>
+          <a:noFill/>
+        </p:spPr>
+        <p:txBody>
+          <a:bodyPr wrap="none" anchor="t" lIns="45720" rIns="45720" tIns="0" bIns="0">
+            <a:spAutoFit/>
+          </a:bodyPr>
+          <a:lstStyle/>
+          <a:p>
+            <a:pPr algn="r"/>
+            <a:r>
+              <a:rPr sz="1100" b="0">
+                <a:solidFill>
+                  <a:srgbClr val="FFFFFF"/>
+                </a:solidFill>
+                <a:latin typeface="Calibri" panose="020F0502020204030204"/>
+                <a:ea typeface="微软雅黑" panose="020B0503020204020204" charset="-122"/>
+                <a:cs typeface="Calibri" panose="020F0502020204030204"/>
+              </a:rPr>
+              <a:t>Confidential</a:t>
+            </a:r>
+          </a:p>
+        </p:txBody>
+      </p:sp>
+      <p:sp>
+        <p:nvSpPr>
+          <p:cNvPr id="7" name="Rounded Rectangle 6"/>
+          <p:cNvSpPr/>
+          <p:nvPr/>
+        </p:nvSpPr>
+        <p:spPr>
+          <a:xfrm>
+            <a:off x="384048" y="841248"/>
+            <a:ext cx="5623560" cy="3794760"/>
+          </a:xfrm>
+          <a:prstGeom prst="roundRect">
+            <a:avLst>
+              <a:gd name="adj" fmla="val 8000"/>
+            </a:avLst>
+          </a:prstGeom>
+          <a:solidFill>
+            <a:srgbClr val="F3F6FB"/>
+          </a:solidFill>
+          <a:ln w="9525">
+            <a:solidFill>
+              <a:srgbClr val="8EA9DB"/>
+            </a:solidFill>
+          </a:ln>
+          <a:effectLst/>
+        </p:spPr>
+        <p:style>
+          <a:lnRef idx="1">
+            <a:schemeClr val="accent1"/>
+          </a:lnRef>
+          <a:fillRef idx="3">
+            <a:schemeClr val="accent1"/>
+          </a:fillRef>
+          <a:effectRef idx="2">
+            <a:schemeClr val="accent1"/>
+          </a:effectRef>
+          <a:fontRef idx="minor">
+            <a:schemeClr val="lt1"/>
+          </a:fontRef>
+        </p:style>
+        <p:txBody>
+          <a:bodyPr rtlCol="0" anchor="ctr"/>
+          <a:lstStyle/>
+          <a:p>
+            <a:pPr algn="ctr"/>
+          </a:p>
+        </p:txBody>
+      </p:sp>
+      <p:pic>
+        <p:nvPicPr>
+          <p:cNvPr id="8" name="Picture 7" descr="image3.jpeg"/>
+          <p:cNvPicPr>
+            <a:picLocks noChangeAspect="1"/>
+          </p:cNvPicPr>
+          <p:nvPr/>
+        </p:nvPicPr>
+        <p:blipFill>
+          <a:blip r:embed="rId3"/>
+          <a:stretch>
+            <a:fillRect/>
+          </a:stretch>
+        </p:blipFill>
+        <p:spPr>
+          <a:xfrm>
+            <a:off x="1260978" y="950976"/>
+            <a:ext cx="3869699" cy="3118104"/>
+          </a:xfrm>
+          <a:prstGeom prst="rect">
+            <a:avLst/>
+          </a:prstGeom>
+          <a:ln w="9525">
+            <a:solidFill>
+              <a:srgbClr val="8EA9DB"/>
+            </a:solidFill>
+          </a:ln>
+        </p:spPr>
+      </p:pic>
+      <p:sp>
+        <p:nvSpPr>
+          <p:cNvPr id="9" name="Oval 8"/>
+          <p:cNvSpPr/>
+          <p:nvPr/>
+        </p:nvSpPr>
+        <p:spPr>
+          <a:xfrm>
+            <a:off x="512064" y="4215384"/>
+            <a:ext cx="274320" cy="274320"/>
+          </a:xfrm>
+          <a:prstGeom prst="ellipse">
+            <a:avLst/>
+          </a:prstGeom>
+          <a:solidFill>
+            <a:srgbClr val="366092"/>
+          </a:solidFill>
+          <a:ln>
+            <a:noFill/>
+          </a:ln>
+          <a:effectLst/>
+        </p:spPr>
+        <p:style>
+          <a:lnRef idx="1">
+            <a:schemeClr val="accent1"/>
+          </a:lnRef>
+          <a:fillRef idx="3">
+            <a:schemeClr val="accent1"/>
+          </a:fillRef>
+          <a:effectRef idx="2">
+            <a:schemeClr val="accent1"/>
+          </a:effectRef>
+          <a:fontRef idx="minor">
+            <a:schemeClr val="lt1"/>
+          </a:fontRef>
+        </p:style>
+        <p:txBody>
+          <a:bodyPr rtlCol="0" anchor="ctr" wrap="none"/>
+          <a:lstStyle/>
+          <a:p>
+            <a:pPr algn="ctr"/>
+            <a:r>
+              <a:rPr sz="1200" b="1">
+                <a:solidFill>
+                  <a:srgbClr val="FFFFFF"/>
+                </a:solidFill>
+                <a:latin typeface="Calibri" panose="020F0502020204030204"/>
+                <a:ea typeface="微软雅黑" panose="020B0503020204020204" charset="-122"/>
+                <a:cs typeface="Calibri" panose="020F0502020204030204"/>
+              </a:rPr>
+              <a:t>1</a:t>
+            </a:r>
+          </a:p>
+        </p:txBody>
+      </p:sp>
+      <p:sp>
+        <p:nvSpPr>
+          <p:cNvPr id="10" name="TextBox 9"/>
+          <p:cNvSpPr txBox="1"/>
+          <p:nvPr/>
+        </p:nvSpPr>
+        <p:spPr>
+          <a:xfrm>
+            <a:off x="859536" y="4197096"/>
+            <a:ext cx="3867912" cy="310896"/>
+          </a:xfrm>
+          <a:prstGeom prst="rect">
+            <a:avLst/>
+          </a:prstGeom>
+          <a:noFill/>
+        </p:spPr>
+        <p:txBody>
+          <a:bodyPr wrap="square" anchor="ctr" lIns="45720" rIns="45720" tIns="0" bIns="0">
+            <a:spAutoFit/>
+          </a:bodyPr>
+          <a:lstStyle/>
+          <a:p>
+            <a:pPr algn="l"/>
+            <a:r>
+              <a:rPr sz="1300" b="1">
+                <a:solidFill>
+                  <a:srgbClr val="366092"/>
+                </a:solidFill>
+                <a:latin typeface="Calibri" panose="020F0502020204030204"/>
+                <a:ea typeface="微软雅黑" panose="020B0503020204020204" charset="-122"/>
+                <a:cs typeface="Calibri" panose="020F0502020204030204"/>
+              </a:rPr>
+              <a:t>1211-HPPC03-AT04 – as found</a:t>
+            </a:r>
+          </a:p>
+        </p:txBody>
+      </p:sp>
+      <p:sp>
+        <p:nvSpPr>
+          <p:cNvPr id="11" name="Rounded Rectangle 10"/>
+          <p:cNvSpPr/>
+          <p:nvPr/>
+        </p:nvSpPr>
+        <p:spPr>
+          <a:xfrm>
+            <a:off x="4818888" y="4233672"/>
+            <a:ext cx="1078992" cy="256032"/>
+          </a:xfrm>
+          <a:prstGeom prst="roundRect">
+            <a:avLst>
+              <a:gd name="adj" fmla="val 50000"/>
+            </a:avLst>
+          </a:prstGeom>
+          <a:solidFill>
+            <a:srgbClr val="C00000"/>
+          </a:solidFill>
+          <a:ln>
+            <a:noFill/>
+          </a:ln>
+          <a:effectLst/>
+        </p:spPr>
+        <p:style>
+          <a:lnRef idx="1">
+            <a:schemeClr val="accent1"/>
+          </a:lnRef>
+          <a:fillRef idx="3">
+            <a:schemeClr val="accent1"/>
+          </a:fillRef>
+          <a:effectRef idx="2">
+            <a:schemeClr val="accent1"/>
+          </a:effectRef>
+          <a:fontRef idx="minor">
+            <a:schemeClr val="lt1"/>
+          </a:fontRef>
+        </p:style>
+        <p:txBody>
+          <a:bodyPr rtlCol="0" anchor="ctr" wrap="none"/>
+          <a:lstStyle/>
+          <a:p>
+            <a:pPr algn="ctr"/>
+            <a:r>
+              <a:rPr sz="900" b="1">
+                <a:solidFill>
+                  <a:srgbClr val="FFFFFF"/>
+                </a:solidFill>
+                <a:latin typeface="Calibri" panose="020F0502020204030204"/>
+                <a:ea typeface="微软雅黑" panose="020B0503020204020204" charset="-122"/>
+                <a:cs typeface="Calibri" panose="020F0502020204030204"/>
+              </a:rPr>
+              <a:t>Not compliant</a:t>
+            </a:r>
+          </a:p>
+        </p:txBody>
+      </p:sp>
+      <p:sp>
+        <p:nvSpPr>
+          <p:cNvPr id="12" name="Rounded Rectangle 11"/>
+          <p:cNvSpPr/>
+          <p:nvPr/>
+        </p:nvSpPr>
+        <p:spPr>
+          <a:xfrm>
+            <a:off x="6181344" y="841248"/>
+            <a:ext cx="5623560" cy="3794760"/>
+          </a:xfrm>
+          <a:prstGeom prst="roundRect">
+            <a:avLst>
+              <a:gd name="adj" fmla="val 8000"/>
+            </a:avLst>
+          </a:prstGeom>
+          <a:solidFill>
+            <a:srgbClr val="F3F6FB"/>
+          </a:solidFill>
+          <a:ln w="9525">
+            <a:solidFill>
+              <a:srgbClr val="8EA9DB"/>
+            </a:solidFill>
+          </a:ln>
+          <a:effectLst/>
+        </p:spPr>
+        <p:style>
+          <a:lnRef idx="1">
+            <a:schemeClr val="accent1"/>
+          </a:lnRef>
+          <a:fillRef idx="3">
+            <a:schemeClr val="accent1"/>
+          </a:fillRef>
+          <a:effectRef idx="2">
+            <a:schemeClr val="accent1"/>
+          </a:effectRef>
+          <a:fontRef idx="minor">
+            <a:schemeClr val="lt1"/>
+          </a:fontRef>
+        </p:style>
+        <p:txBody>
+          <a:bodyPr rtlCol="0" anchor="ctr"/>
+          <a:lstStyle/>
+          <a:p>
+            <a:pPr algn="ctr"/>
+          </a:p>
+        </p:txBody>
+      </p:sp>
+      <p:pic>
+        <p:nvPicPr>
+          <p:cNvPr id="13" name="Picture 12" descr="image2.jpeg"/>
+          <p:cNvPicPr>
+            <a:picLocks noChangeAspect="1"/>
+          </p:cNvPicPr>
+          <p:nvPr/>
+        </p:nvPicPr>
+        <p:blipFill>
+          <a:blip r:embed="rId4"/>
+          <a:stretch>
+            <a:fillRect/>
+          </a:stretch>
+        </p:blipFill>
+        <p:spPr>
+          <a:xfrm>
+            <a:off x="6891460" y="950976"/>
+            <a:ext cx="4203326" cy="3118104"/>
+          </a:xfrm>
+          <a:prstGeom prst="rect">
+            <a:avLst/>
+          </a:prstGeom>
+          <a:ln w="9525">
+            <a:solidFill>
+              <a:srgbClr val="8EA9DB"/>
+            </a:solidFill>
+          </a:ln>
+        </p:spPr>
+      </p:pic>
+      <p:sp>
+        <p:nvSpPr>
+          <p:cNvPr id="14" name="Oval 13"/>
+          <p:cNvSpPr/>
+          <p:nvPr/>
+        </p:nvSpPr>
+        <p:spPr>
+          <a:xfrm>
+            <a:off x="6309359" y="4215384"/>
+            <a:ext cx="274320" cy="274320"/>
+          </a:xfrm>
+          <a:prstGeom prst="ellipse">
+            <a:avLst/>
+          </a:prstGeom>
+          <a:solidFill>
+            <a:srgbClr val="366092"/>
+          </a:solidFill>
+          <a:ln>
+            <a:noFill/>
+          </a:ln>
+          <a:effectLst/>
+        </p:spPr>
+        <p:style>
+          <a:lnRef idx="1">
+            <a:schemeClr val="accent1"/>
+          </a:lnRef>
+          <a:fillRef idx="3">
+            <a:schemeClr val="accent1"/>
+          </a:fillRef>
+          <a:effectRef idx="2">
+            <a:schemeClr val="accent1"/>
+          </a:effectRef>
+          <a:fontRef idx="minor">
+            <a:schemeClr val="lt1"/>
+          </a:fontRef>
+        </p:style>
+        <p:txBody>
+          <a:bodyPr rtlCol="0" anchor="ctr" wrap="none"/>
+          <a:lstStyle/>
+          <a:p>
+            <a:pPr algn="ctr"/>
+            <a:r>
+              <a:rPr sz="1200" b="1">
+                <a:solidFill>
+                  <a:srgbClr val="FFFFFF"/>
+                </a:solidFill>
+                <a:latin typeface="Calibri" panose="020F0502020204030204"/>
+                <a:ea typeface="微软雅黑" panose="020B0503020204020204" charset="-122"/>
+                <a:cs typeface="Calibri" panose="020F0502020204030204"/>
+              </a:rPr>
+              <a:t>2</a:t>
+            </a:r>
+          </a:p>
+        </p:txBody>
+      </p:sp>
+      <p:sp>
+        <p:nvSpPr>
+          <p:cNvPr id="15" name="TextBox 14"/>
+          <p:cNvSpPr txBox="1"/>
+          <p:nvPr/>
+        </p:nvSpPr>
+        <p:spPr>
+          <a:xfrm>
+            <a:off x="6656831" y="4197096"/>
+            <a:ext cx="3867912" cy="310896"/>
+          </a:xfrm>
+          <a:prstGeom prst="rect">
+            <a:avLst/>
+          </a:prstGeom>
+          <a:noFill/>
+        </p:spPr>
+        <p:txBody>
+          <a:bodyPr wrap="square" anchor="ctr" lIns="45720" rIns="45720" tIns="0" bIns="0">
+            <a:spAutoFit/>
+          </a:bodyPr>
+          <a:lstStyle/>
+          <a:p>
+            <a:pPr algn="l"/>
+            <a:r>
+              <a:rPr sz="1300" b="1">
+                <a:solidFill>
+                  <a:srgbClr val="366092"/>
+                </a:solidFill>
+                <a:latin typeface="Calibri" panose="020F0502020204030204"/>
+                <a:ea typeface="微软雅黑" panose="020B0503020204020204" charset="-122"/>
+                <a:cs typeface="Calibri" panose="020F0502020204030204"/>
+              </a:rPr>
+              <a:t>1211-HPPC03-AT03 – reference</a:t>
+            </a:r>
+          </a:p>
+        </p:txBody>
+      </p:sp>
+      <p:sp>
+        <p:nvSpPr>
+          <p:cNvPr id="16" name="Rounded Rectangle 15"/>
+          <p:cNvSpPr/>
+          <p:nvPr/>
+        </p:nvSpPr>
+        <p:spPr>
+          <a:xfrm>
+            <a:off x="10616184" y="4233672"/>
+            <a:ext cx="1078992" cy="256032"/>
+          </a:xfrm>
+          <a:prstGeom prst="roundRect">
+            <a:avLst>
+              <a:gd name="adj" fmla="val 50000"/>
+            </a:avLst>
+          </a:prstGeom>
+          <a:solidFill>
+            <a:srgbClr val="2E7D32"/>
+          </a:solidFill>
+          <a:ln>
+            <a:noFill/>
+          </a:ln>
+          <a:effectLst/>
+        </p:spPr>
+        <p:style>
+          <a:lnRef idx="1">
+            <a:schemeClr val="accent1"/>
+          </a:lnRef>
+          <a:fillRef idx="3">
+            <a:schemeClr val="accent1"/>
+          </a:fillRef>
+          <a:effectRef idx="2">
+            <a:schemeClr val="accent1"/>
+          </a:effectRef>
+          <a:fontRef idx="minor">
+            <a:schemeClr val="lt1"/>
+          </a:fontRef>
+        </p:style>
+        <p:txBody>
+          <a:bodyPr rtlCol="0" anchor="ctr" wrap="none"/>
+          <a:lstStyle/>
+          <a:p>
+            <a:pPr algn="ctr"/>
+            <a:r>
+              <a:rPr sz="900" b="1">
+                <a:solidFill>
+                  <a:srgbClr val="FFFFFF"/>
+                </a:solidFill>
+                <a:latin typeface="Calibri" panose="020F0502020204030204"/>
+                <a:ea typeface="微软雅黑" panose="020B0503020204020204" charset="-122"/>
+                <a:cs typeface="Calibri" panose="020F0502020204030204"/>
+              </a:rPr>
+              <a:t>Compliant</a:t>
+            </a:r>
+          </a:p>
+        </p:txBody>
+      </p:sp>
+      <p:sp>
+        <p:nvSpPr>
+          <p:cNvPr id="17" name="Rounded Rectangle 16"/>
+          <p:cNvSpPr/>
+          <p:nvPr/>
+        </p:nvSpPr>
+        <p:spPr>
+          <a:xfrm>
+            <a:off x="384048" y="4800600"/>
+            <a:ext cx="3672840" cy="1408176"/>
+          </a:xfrm>
+          <a:prstGeom prst="roundRect">
+            <a:avLst>
+              <a:gd name="adj" fmla="val 8000"/>
+            </a:avLst>
+          </a:prstGeom>
+          <a:solidFill>
+            <a:srgbClr val="F3F6FB"/>
+          </a:solidFill>
+          <a:ln w="9525">
+            <a:solidFill>
+              <a:srgbClr val="8EA9DB"/>
+            </a:solidFill>
+          </a:ln>
+          <a:effectLst/>
+        </p:spPr>
+        <p:style>
+          <a:lnRef idx="1">
+            <a:schemeClr val="accent1"/>
+          </a:lnRef>
+          <a:fillRef idx="3">
+            <a:schemeClr val="accent1"/>
+          </a:fillRef>
+          <a:effectRef idx="2">
+            <a:schemeClr val="accent1"/>
+          </a:effectRef>
+          <a:fontRef idx="minor">
+            <a:schemeClr val="lt1"/>
+          </a:fontRef>
+        </p:style>
+        <p:txBody>
+          <a:bodyPr rtlCol="0" anchor="ctr"/>
+          <a:lstStyle/>
+          <a:p>
+            <a:pPr algn="ctr"/>
+          </a:p>
+        </p:txBody>
+      </p:sp>
+      <p:sp>
+        <p:nvSpPr>
+          <p:cNvPr id="18" name="Oval 17"/>
+          <p:cNvSpPr/>
+          <p:nvPr/>
+        </p:nvSpPr>
+        <p:spPr>
+          <a:xfrm>
+            <a:off x="512064" y="4928616"/>
+            <a:ext cx="274320" cy="274320"/>
+          </a:xfrm>
+          <a:prstGeom prst="ellipse">
+            <a:avLst/>
+          </a:prstGeom>
+          <a:solidFill>
+            <a:srgbClr val="366092"/>
+          </a:solidFill>
+          <a:ln>
+            <a:noFill/>
+          </a:ln>
+          <a:effectLst/>
+        </p:spPr>
+        <p:style>
+          <a:lnRef idx="1">
+            <a:schemeClr val="accent1"/>
+          </a:lnRef>
+          <a:fillRef idx="3">
+            <a:schemeClr val="accent1"/>
+          </a:fillRef>
+          <a:effectRef idx="2">
+            <a:schemeClr val="accent1"/>
+          </a:effectRef>
+          <a:fontRef idx="minor">
+            <a:schemeClr val="lt1"/>
+          </a:fontRef>
+        </p:style>
+        <p:txBody>
+          <a:bodyPr rtlCol="0" anchor="ctr" wrap="none"/>
+          <a:lstStyle/>
+          <a:p>
+            <a:pPr algn="ctr"/>
+            <a:r>
+              <a:rPr sz="1200" b="1">
+                <a:solidFill>
+                  <a:srgbClr val="FFFFFF"/>
+                </a:solidFill>
+                <a:latin typeface="Calibri" panose="020F0502020204030204"/>
+                <a:ea typeface="微软雅黑" panose="020B0503020204020204" charset="-122"/>
+                <a:cs typeface="Calibri" panose="020F0502020204030204"/>
+              </a:rPr>
+              <a:t>1</a:t>
+            </a:r>
+          </a:p>
+        </p:txBody>
+      </p:sp>
+      <p:sp>
+        <p:nvSpPr>
+          <p:cNvPr id="19" name="TextBox 18"/>
+          <p:cNvSpPr txBox="1"/>
+          <p:nvPr/>
+        </p:nvSpPr>
+        <p:spPr>
+          <a:xfrm>
+            <a:off x="859536" y="4910328"/>
+            <a:ext cx="3032760" cy="310896"/>
+          </a:xfrm>
+          <a:prstGeom prst="rect">
+            <a:avLst/>
+          </a:prstGeom>
+          <a:noFill/>
+        </p:spPr>
+        <p:txBody>
+          <a:bodyPr wrap="square" anchor="ctr" lIns="45720" rIns="45720" tIns="0" bIns="0">
+            <a:spAutoFit/>
+          </a:bodyPr>
+          <a:lstStyle/>
+          <a:p>
+            <a:pPr algn="l"/>
+            <a:r>
+              <a:rPr sz="1400" b="1">
+                <a:solidFill>
+                  <a:srgbClr val="366092"/>
+                </a:solidFill>
+                <a:latin typeface="Calibri" panose="020F0502020204030204"/>
+                <a:ea typeface="微软雅黑" panose="020B0503020204020204" charset="-122"/>
+                <a:cs typeface="Calibri" panose="020F0502020204030204"/>
+              </a:rPr>
+              <a:t>Finding</a:t>
+            </a:r>
+          </a:p>
+        </p:txBody>
+      </p:sp>
+      <p:sp>
+        <p:nvSpPr>
+          <p:cNvPr id="20" name="TextBox 19"/>
+          <p:cNvSpPr txBox="1"/>
+          <p:nvPr/>
+        </p:nvSpPr>
+        <p:spPr>
+          <a:xfrm>
+            <a:off x="548640" y="5303520"/>
+            <a:ext cx="3343656" cy="850392"/>
+          </a:xfrm>
+          <a:prstGeom prst="rect">
+            <a:avLst/>
+          </a:prstGeom>
+          <a:noFill/>
+        </p:spPr>
+        <p:txBody>
+          <a:bodyPr wrap="square" anchor="t" lIns="45720" rIns="45720" tIns="0" bIns="0">
+            <a:spAutoFit/>
+          </a:bodyPr>
+          <a:lstStyle/>
+          <a:p>
+            <a:pPr algn="l">
+              <a:spcAft>
+                <a:spcPts val="400"/>
+              </a:spcAft>
+            </a:pPr>
+            <a:r>
+              <a:rPr sz="1200" b="0">
+                <a:solidFill>
+                  <a:srgbClr val="222222"/>
+                </a:solidFill>
+                <a:latin typeface="Calibri" panose="020F0502020204030204"/>
+                <a:ea typeface="微软雅黑" panose="020B0503020204020204" charset="-122"/>
+                <a:cs typeface="Calibri" panose="020F0502020204030204"/>
+              </a:rPr>
+              <a:t>Agitation in 1211-HPPC03-AT04 does not meet the requirement.</a:t>
+            </a:r>
+          </a:p>
+          <a:p>
+            <a:pPr algn="l">
+              <a:spcAft>
+                <a:spcPts val="400"/>
+              </a:spcAft>
+            </a:pPr>
+            <a:r>
+              <a:rPr sz="1200" b="0">
+                <a:solidFill>
+                  <a:srgbClr val="222222"/>
+                </a:solidFill>
+                <a:latin typeface="Calibri" panose="020F0502020204030204"/>
+                <a:ea typeface="微软雅黑" panose="020B0503020204020204" charset="-122"/>
+                <a:cs typeface="Calibri" panose="020F0502020204030204"/>
+              </a:rPr>
+              <a:t>AT03, AT05 and AT06 are acceptable.</a:t>
+            </a:r>
+          </a:p>
+        </p:txBody>
+      </p:sp>
+      <p:sp>
+        <p:nvSpPr>
+          <p:cNvPr id="21" name="Rounded Rectangle 20"/>
+          <p:cNvSpPr/>
+          <p:nvPr/>
+        </p:nvSpPr>
+        <p:spPr>
+          <a:xfrm>
+            <a:off x="4258056" y="4800600"/>
+            <a:ext cx="3672840" cy="1408176"/>
+          </a:xfrm>
+          <a:prstGeom prst="roundRect">
+            <a:avLst>
+              <a:gd name="adj" fmla="val 8000"/>
+            </a:avLst>
+          </a:prstGeom>
+          <a:solidFill>
+            <a:srgbClr val="F3F6FB"/>
+          </a:solidFill>
+          <a:ln w="9525">
+            <a:solidFill>
+              <a:srgbClr val="8EA9DB"/>
+            </a:solidFill>
+          </a:ln>
+          <a:effectLst/>
+        </p:spPr>
+        <p:style>
+          <a:lnRef idx="1">
+            <a:schemeClr val="accent1"/>
+          </a:lnRef>
+          <a:fillRef idx="3">
+            <a:schemeClr val="accent1"/>
+          </a:fillRef>
+          <a:effectRef idx="2">
+            <a:schemeClr val="accent1"/>
+          </a:effectRef>
+          <a:fontRef idx="minor">
+            <a:schemeClr val="lt1"/>
+          </a:fontRef>
+        </p:style>
+        <p:txBody>
+          <a:bodyPr rtlCol="0" anchor="ctr"/>
+          <a:lstStyle/>
+          <a:p>
+            <a:pPr algn="ctr"/>
+          </a:p>
+        </p:txBody>
+      </p:sp>
+      <p:sp>
+        <p:nvSpPr>
+          <p:cNvPr id="22" name="Oval 21"/>
+          <p:cNvSpPr/>
+          <p:nvPr/>
+        </p:nvSpPr>
+        <p:spPr>
+          <a:xfrm>
+            <a:off x="4386071" y="4928616"/>
+            <a:ext cx="274320" cy="274320"/>
+          </a:xfrm>
+          <a:prstGeom prst="ellipse">
+            <a:avLst/>
+          </a:prstGeom>
+          <a:solidFill>
+            <a:srgbClr val="366092"/>
+          </a:solidFill>
+          <a:ln>
+            <a:noFill/>
+          </a:ln>
+          <a:effectLst/>
+        </p:spPr>
+        <p:style>
+          <a:lnRef idx="1">
+            <a:schemeClr val="accent1"/>
+          </a:lnRef>
+          <a:fillRef idx="3">
+            <a:schemeClr val="accent1"/>
+          </a:fillRef>
+          <a:effectRef idx="2">
+            <a:schemeClr val="accent1"/>
+          </a:effectRef>
+          <a:fontRef idx="minor">
+            <a:schemeClr val="lt1"/>
+          </a:fontRef>
+        </p:style>
+        <p:txBody>
+          <a:bodyPr rtlCol="0" anchor="ctr" wrap="none"/>
+          <a:lstStyle/>
+          <a:p>
+            <a:pPr algn="ctr"/>
+            <a:r>
+              <a:rPr sz="1200" b="1">
+                <a:solidFill>
+                  <a:srgbClr val="FFFFFF"/>
+                </a:solidFill>
+                <a:latin typeface="Calibri" panose="020F0502020204030204"/>
+                <a:ea typeface="微软雅黑" panose="020B0503020204020204" charset="-122"/>
+                <a:cs typeface="Calibri" panose="020F0502020204030204"/>
+              </a:rPr>
+              <a:t>2</a:t>
+            </a:r>
+          </a:p>
+        </p:txBody>
+      </p:sp>
+      <p:sp>
+        <p:nvSpPr>
+          <p:cNvPr id="23" name="TextBox 22"/>
+          <p:cNvSpPr txBox="1"/>
+          <p:nvPr/>
+        </p:nvSpPr>
+        <p:spPr>
+          <a:xfrm>
+            <a:off x="4733543" y="4910328"/>
+            <a:ext cx="3032760" cy="310896"/>
+          </a:xfrm>
+          <a:prstGeom prst="rect">
+            <a:avLst/>
+          </a:prstGeom>
+          <a:noFill/>
+        </p:spPr>
+        <p:txBody>
+          <a:bodyPr wrap="square" anchor="ctr" lIns="45720" rIns="45720" tIns="0" bIns="0">
+            <a:spAutoFit/>
+          </a:bodyPr>
+          <a:lstStyle/>
+          <a:p>
+            <a:pPr algn="l"/>
+            <a:r>
+              <a:rPr sz="1400" b="1">
+                <a:solidFill>
+                  <a:srgbClr val="366092"/>
+                </a:solidFill>
+                <a:latin typeface="Calibri" panose="020F0502020204030204"/>
+                <a:ea typeface="微软雅黑" panose="020B0503020204020204" charset="-122"/>
+                <a:cs typeface="Calibri" panose="020F0502020204030204"/>
+              </a:rPr>
+              <a:t>Action</a:t>
+            </a:r>
+          </a:p>
+        </p:txBody>
+      </p:sp>
+      <p:sp>
+        <p:nvSpPr>
+          <p:cNvPr id="24" name="TextBox 23"/>
+          <p:cNvSpPr txBox="1"/>
+          <p:nvPr/>
+        </p:nvSpPr>
+        <p:spPr>
+          <a:xfrm>
+            <a:off x="4422647" y="5303520"/>
+            <a:ext cx="3343656" cy="850392"/>
+          </a:xfrm>
+          <a:prstGeom prst="rect">
+            <a:avLst/>
+          </a:prstGeom>
+          <a:noFill/>
+        </p:spPr>
+        <p:txBody>
+          <a:bodyPr wrap="square" anchor="t" lIns="45720" rIns="45720" tIns="0" bIns="0">
+            <a:spAutoFit/>
+          </a:bodyPr>
+          <a:lstStyle/>
+          <a:p>
+            <a:pPr algn="l">
+              <a:spcAft>
+                <a:spcPts val="400"/>
+              </a:spcAft>
+            </a:pPr>
+            <a:r>
+              <a:rPr sz="1200" b="0">
+                <a:solidFill>
+                  <a:srgbClr val="222222"/>
+                </a:solidFill>
+                <a:latin typeface="Calibri" panose="020F0502020204030204"/>
+                <a:ea typeface="微软雅黑" panose="020B0503020204020204" charset="-122"/>
+                <a:cs typeface="Calibri" panose="020F0502020204030204"/>
+              </a:rPr>
+              <a:t>Rectify the AT04 agitation, then repeat the photo check to confirm the pattern.</a:t>
+            </a:r>
+          </a:p>
+        </p:txBody>
+      </p:sp>
+      <p:sp>
+        <p:nvSpPr>
+          <p:cNvPr id="25" name="Rounded Rectangle 24"/>
+          <p:cNvSpPr/>
+          <p:nvPr/>
+        </p:nvSpPr>
+        <p:spPr>
+          <a:xfrm>
+            <a:off x="8132063" y="4800600"/>
+            <a:ext cx="3672840" cy="1408176"/>
+          </a:xfrm>
+          <a:prstGeom prst="roundRect">
+            <a:avLst>
+              <a:gd name="adj" fmla="val 8000"/>
+            </a:avLst>
+          </a:prstGeom>
+          <a:solidFill>
+            <a:srgbClr val="F3F6FB"/>
+          </a:solidFill>
+          <a:ln w="9525">
+            <a:solidFill>
+              <a:srgbClr val="8EA9DB"/>
+            </a:solidFill>
+          </a:ln>
+          <a:effectLst/>
+        </p:spPr>
+        <p:style>
+          <a:lnRef idx="1">
+            <a:schemeClr val="accent1"/>
+          </a:lnRef>
+          <a:fillRef idx="3">
+            <a:schemeClr val="accent1"/>
+          </a:fillRef>
+          <a:effectRef idx="2">
+            <a:schemeClr val="accent1"/>
+          </a:effectRef>
+          <a:fontRef idx="minor">
+            <a:schemeClr val="lt1"/>
+          </a:fontRef>
+        </p:style>
+        <p:txBody>
+          <a:bodyPr rtlCol="0" anchor="ctr"/>
+          <a:lstStyle/>
+          <a:p>
+            <a:pPr algn="ctr"/>
+          </a:p>
+        </p:txBody>
+      </p:sp>
+      <p:sp>
+        <p:nvSpPr>
+          <p:cNvPr id="26" name="Oval 25"/>
+          <p:cNvSpPr/>
+          <p:nvPr/>
+        </p:nvSpPr>
+        <p:spPr>
+          <a:xfrm>
+            <a:off x="8260080" y="4928616"/>
+            <a:ext cx="274320" cy="274320"/>
+          </a:xfrm>
+          <a:prstGeom prst="ellipse">
+            <a:avLst/>
+          </a:prstGeom>
+          <a:solidFill>
+            <a:srgbClr val="366092"/>
+          </a:solidFill>
+          <a:ln>
+            <a:noFill/>
+          </a:ln>
+          <a:effectLst/>
+        </p:spPr>
+        <p:style>
+          <a:lnRef idx="1">
+            <a:schemeClr val="accent1"/>
+          </a:lnRef>
+          <a:fillRef idx="3">
+            <a:schemeClr val="accent1"/>
+          </a:fillRef>
+          <a:effectRef idx="2">
+            <a:schemeClr val="accent1"/>
+          </a:effectRef>
+          <a:fontRef idx="minor">
+            <a:schemeClr val="lt1"/>
+          </a:fontRef>
+        </p:style>
+        <p:txBody>
+          <a:bodyPr rtlCol="0" anchor="ctr" wrap="none"/>
+          <a:lstStyle/>
+          <a:p>
+            <a:pPr algn="ctr"/>
+            <a:r>
+              <a:rPr sz="1200" b="1">
+                <a:solidFill>
+                  <a:srgbClr val="FFFFFF"/>
+                </a:solidFill>
+                <a:latin typeface="Calibri" panose="020F0502020204030204"/>
+                <a:ea typeface="微软雅黑" panose="020B0503020204020204" charset="-122"/>
+                <a:cs typeface="Calibri" panose="020F0502020204030204"/>
+              </a:rPr>
+              <a:t>3</a:t>
+            </a:r>
+          </a:p>
+        </p:txBody>
+      </p:sp>
+      <p:sp>
+        <p:nvSpPr>
+          <p:cNvPr id="27" name="TextBox 26"/>
+          <p:cNvSpPr txBox="1"/>
+          <p:nvPr/>
+        </p:nvSpPr>
+        <p:spPr>
+          <a:xfrm>
+            <a:off x="8607551" y="4910328"/>
+            <a:ext cx="3032760" cy="310896"/>
+          </a:xfrm>
+          <a:prstGeom prst="rect">
+            <a:avLst/>
+          </a:prstGeom>
+          <a:noFill/>
+        </p:spPr>
+        <p:txBody>
+          <a:bodyPr wrap="square" anchor="ctr" lIns="45720" rIns="45720" tIns="0" bIns="0">
+            <a:spAutoFit/>
+          </a:bodyPr>
+          <a:lstStyle/>
+          <a:p>
+            <a:pPr algn="l"/>
+            <a:r>
+              <a:rPr sz="1400" b="1">
+                <a:solidFill>
+                  <a:srgbClr val="366092"/>
+                </a:solidFill>
+                <a:latin typeface="Calibri" panose="020F0502020204030204"/>
+                <a:ea typeface="微软雅黑" panose="020B0503020204020204" charset="-122"/>
+                <a:cs typeface="Calibri" panose="020F0502020204030204"/>
+              </a:rPr>
+              <a:t>Timing</a:t>
+            </a:r>
+          </a:p>
+        </p:txBody>
+      </p:sp>
+      <p:sp>
+        <p:nvSpPr>
+          <p:cNvPr id="28" name="TextBox 27"/>
+          <p:cNvSpPr txBox="1"/>
+          <p:nvPr/>
+        </p:nvSpPr>
+        <p:spPr>
+          <a:xfrm>
+            <a:off x="8296655" y="5303520"/>
+            <a:ext cx="3343656" cy="850392"/>
+          </a:xfrm>
+          <a:prstGeom prst="rect">
+            <a:avLst/>
+          </a:prstGeom>
+          <a:noFill/>
+        </p:spPr>
+        <p:txBody>
+          <a:bodyPr wrap="square" anchor="t" lIns="45720" rIns="45720" tIns="0" bIns="0">
+            <a:spAutoFit/>
+          </a:bodyPr>
+          <a:lstStyle/>
+          <a:p>
+            <a:pPr algn="l">
+              <a:spcAft>
+                <a:spcPts val="400"/>
+              </a:spcAft>
+            </a:pPr>
+            <a:r>
+              <a:rPr sz="1200" b="0">
+                <a:solidFill>
+                  <a:srgbClr val="222222"/>
+                </a:solidFill>
+                <a:latin typeface="Calibri" panose="020F0502020204030204"/>
+                <a:ea typeface="微软雅黑" panose="020B0503020204020204" charset="-122"/>
+                <a:cs typeface="Calibri" panose="020F0502020204030204"/>
+              </a:rPr>
+              <a:t>Rectification is completed before PPQ.</a:t>
+            </a:r>
+          </a:p>
+        </p:txBody>
+      </p:sp>
+    </p:spTree>
+  </p:cSld>
+  <p:clrMapOvr>
+    <a:masterClrMapping/>
+  </p:clrMapOvr>
+</p:sld>
+</file>
+
 <file path=ppt/theme/theme1.xml><?xml version="1.0" encoding="utf-8"?>
 <a:theme xmlns:a="http://schemas.openxmlformats.org/drawingml/2006/main" name="Office Theme">
   <a:themeElements>

</xml_diff>